<commit_message>
Update Mathew Scaria Final Presentation.pptx
</commit_message>
<xml_diff>
--- a/Mathew Scaria Final Presentation.pptx
+++ b/Mathew Scaria Final Presentation.pptx
@@ -6,6 +6,15 @@
   </p:sldMasterIdLst>
   <p:sldIdLst>
     <p:sldId id="256" r:id="rId2"/>
+    <p:sldId id="257" r:id="rId3"/>
+    <p:sldId id="258" r:id="rId4"/>
+    <p:sldId id="262" r:id="rId5"/>
+    <p:sldId id="263" r:id="rId6"/>
+    <p:sldId id="264" r:id="rId7"/>
+    <p:sldId id="265" r:id="rId8"/>
+    <p:sldId id="259" r:id="rId9"/>
+    <p:sldId id="261" r:id="rId10"/>
+    <p:sldId id="260" r:id="rId11"/>
   </p:sldIdLst>
   <p:sldSz cx="12192000" cy="6858000"/>
   <p:notesSz cx="6858000" cy="9144000"/>
@@ -104,15 +113,28 @@
       </a:defRPr>
     </a:lvl9pPr>
   </p:defaultTextStyle>
+  <p:extLst>
+    <p:ext uri="{EFAFB233-063F-42B5-8137-9DF3F51BA10A}">
+      <p15:sldGuideLst xmlns:p15="http://schemas.microsoft.com/office/powerpoint/2012/main"/>
+    </p:ext>
+  </p:extLst>
 </p:presentation>
+</file>
+
+<file path=ppt/revisionInfo.xml><?xml version="1.0" encoding="utf-8"?>
+<p1510:revInfo xmlns:a="http://schemas.openxmlformats.org/drawingml/2006/main" xmlns:r="http://schemas.openxmlformats.org/officeDocument/2006/relationships" xmlns:p1510="http://schemas.microsoft.com/office/powerpoint/2015/10/main">
+  <p1510:revLst>
+    <p1510:client id="{6F7A0725-E3B2-44C2-9B37-1E4913143E3B}" v="35" dt="2026-05-12T10:26:48.296"/>
+  </p1510:revLst>
+</p1510:revInfo>
 </file>
 
 <file path=ppt/changesInfos/changesInfo1.xml><?xml version="1.0" encoding="utf-8"?>
 <pc:chgInfo xmlns:a="http://schemas.openxmlformats.org/drawingml/2006/main" xmlns:r="http://schemas.openxmlformats.org/officeDocument/2006/relationships" xmlns:ac="http://schemas.microsoft.com/office/drawing/2013/main/command" xmlns:pc="http://schemas.microsoft.com/office/powerpoint/2013/main/command">
   <pc:docChgLst>
     <pc:chgData name="Mathew Scaria" userId="3974405e373567ab" providerId="LiveId" clId="{2DD90D6B-2F61-4982-A7A9-64CA15CE61DE}"/>
-    <pc:docChg chg="custSel addSld modSld">
-      <pc:chgData name="Mathew Scaria" userId="3974405e373567ab" providerId="LiveId" clId="{2DD90D6B-2F61-4982-A7A9-64CA15CE61DE}" dt="2026-05-08T20:45:26.305" v="66" actId="20577"/>
+    <pc:docChg chg="undo custSel addSld modSld sldOrd">
+      <pc:chgData name="Mathew Scaria" userId="3974405e373567ab" providerId="LiveId" clId="{2DD90D6B-2F61-4982-A7A9-64CA15CE61DE}" dt="2026-05-12T10:36:23.533" v="839" actId="1076"/>
       <pc:docMkLst>
         <pc:docMk/>
       </pc:docMkLst>
@@ -139,6 +161,517 @@
           </ac:spMkLst>
         </pc:spChg>
       </pc:sldChg>
+      <pc:sldChg chg="addSp modSp new mod">
+        <pc:chgData name="Mathew Scaria" userId="3974405e373567ab" providerId="LiveId" clId="{2DD90D6B-2F61-4982-A7A9-64CA15CE61DE}" dt="2026-05-12T10:01:50.866" v="792" actId="1076"/>
+        <pc:sldMkLst>
+          <pc:docMk/>
+          <pc:sldMk cId="696866887" sldId="257"/>
+        </pc:sldMkLst>
+        <pc:spChg chg="mod">
+          <ac:chgData name="Mathew Scaria" userId="3974405e373567ab" providerId="LiveId" clId="{2DD90D6B-2F61-4982-A7A9-64CA15CE61DE}" dt="2026-05-10T22:29:58.261" v="72" actId="20577"/>
+          <ac:spMkLst>
+            <pc:docMk/>
+            <pc:sldMk cId="696866887" sldId="257"/>
+            <ac:spMk id="2" creationId="{8029751E-C0FC-5E6E-2304-5276104486F3}"/>
+          </ac:spMkLst>
+        </pc:spChg>
+        <pc:spChg chg="add mod">
+          <ac:chgData name="Mathew Scaria" userId="3974405e373567ab" providerId="LiveId" clId="{2DD90D6B-2F61-4982-A7A9-64CA15CE61DE}" dt="2026-05-12T10:01:47.640" v="791" actId="20577"/>
+          <ac:spMkLst>
+            <pc:docMk/>
+            <pc:sldMk cId="696866887" sldId="257"/>
+            <ac:spMk id="3" creationId="{9FDB1765-415D-8A50-0123-6B10E598B749}"/>
+          </ac:spMkLst>
+        </pc:spChg>
+        <pc:picChg chg="add mod">
+          <ac:chgData name="Mathew Scaria" userId="3974405e373567ab" providerId="LiveId" clId="{2DD90D6B-2F61-4982-A7A9-64CA15CE61DE}" dt="2026-05-12T10:01:50.866" v="792" actId="1076"/>
+          <ac:picMkLst>
+            <pc:docMk/>
+            <pc:sldMk cId="696866887" sldId="257"/>
+            <ac:picMk id="5" creationId="{E7A385A5-044D-9747-7FF8-1819C7CE0755}"/>
+          </ac:picMkLst>
+        </pc:picChg>
+      </pc:sldChg>
+      <pc:sldChg chg="addSp delSp modSp add mod">
+        <pc:chgData name="Mathew Scaria" userId="3974405e373567ab" providerId="LiveId" clId="{2DD90D6B-2F61-4982-A7A9-64CA15CE61DE}" dt="2026-05-12T09:18:26.059" v="754" actId="20577"/>
+        <pc:sldMkLst>
+          <pc:docMk/>
+          <pc:sldMk cId="3782647756" sldId="258"/>
+        </pc:sldMkLst>
+        <pc:spChg chg="mod">
+          <ac:chgData name="Mathew Scaria" userId="3974405e373567ab" providerId="LiveId" clId="{2DD90D6B-2F61-4982-A7A9-64CA15CE61DE}" dt="2026-05-10T22:36:04.320" v="133" actId="20577"/>
+          <ac:spMkLst>
+            <pc:docMk/>
+            <pc:sldMk cId="3782647756" sldId="258"/>
+            <ac:spMk id="2" creationId="{87B8F006-B50D-2B02-A0EB-288F977AD3DF}"/>
+          </ac:spMkLst>
+        </pc:spChg>
+        <pc:spChg chg="mod">
+          <ac:chgData name="Mathew Scaria" userId="3974405e373567ab" providerId="LiveId" clId="{2DD90D6B-2F61-4982-A7A9-64CA15CE61DE}" dt="2026-05-12T09:18:26.059" v="754" actId="20577"/>
+          <ac:spMkLst>
+            <pc:docMk/>
+            <pc:sldMk cId="3782647756" sldId="258"/>
+            <ac:spMk id="3" creationId="{5FC528D7-F7D4-2BD2-8811-E813BCAB9628}"/>
+          </ac:spMkLst>
+        </pc:spChg>
+        <pc:spChg chg="add">
+          <ac:chgData name="Mathew Scaria" userId="3974405e373567ab" providerId="LiveId" clId="{2DD90D6B-2F61-4982-A7A9-64CA15CE61DE}" dt="2026-05-12T09:02:17.129" v="700"/>
+          <ac:spMkLst>
+            <pc:docMk/>
+            <pc:sldMk cId="3782647756" sldId="258"/>
+            <ac:spMk id="9" creationId="{208F1E66-FBE7-D0B4-C5AF-D1B9057E2D8C}"/>
+          </ac:spMkLst>
+        </pc:spChg>
+        <pc:spChg chg="add">
+          <ac:chgData name="Mathew Scaria" userId="3974405e373567ab" providerId="LiveId" clId="{2DD90D6B-2F61-4982-A7A9-64CA15CE61DE}" dt="2026-05-12T09:02:36.327" v="704"/>
+          <ac:spMkLst>
+            <pc:docMk/>
+            <pc:sldMk cId="3782647756" sldId="258"/>
+            <ac:spMk id="10" creationId="{D53C07F2-5AF3-FA80-CADE-3B85419C5A7F}"/>
+          </ac:spMkLst>
+        </pc:spChg>
+        <pc:picChg chg="add del mod">
+          <ac:chgData name="Mathew Scaria" userId="3974405e373567ab" providerId="LiveId" clId="{2DD90D6B-2F61-4982-A7A9-64CA15CE61DE}" dt="2026-05-12T08:22:17.634" v="681" actId="478"/>
+          <ac:picMkLst>
+            <pc:docMk/>
+            <pc:sldMk cId="3782647756" sldId="258"/>
+            <ac:picMk id="5" creationId="{136D6A22-E7D3-5A09-230F-3F0E20889F71}"/>
+          </ac:picMkLst>
+        </pc:picChg>
+        <pc:picChg chg="add del mod">
+          <ac:chgData name="Mathew Scaria" userId="3974405e373567ab" providerId="LiveId" clId="{2DD90D6B-2F61-4982-A7A9-64CA15CE61DE}" dt="2026-05-12T08:23:44.527" v="689" actId="478"/>
+          <ac:picMkLst>
+            <pc:docMk/>
+            <pc:sldMk cId="3782647756" sldId="258"/>
+            <ac:picMk id="6" creationId="{79640BB5-D5B9-ADC5-2AC4-4AA874F18897}"/>
+          </ac:picMkLst>
+        </pc:picChg>
+        <pc:picChg chg="add mod">
+          <ac:chgData name="Mathew Scaria" userId="3974405e373567ab" providerId="LiveId" clId="{2DD90D6B-2F61-4982-A7A9-64CA15CE61DE}" dt="2026-05-12T09:12:26.848" v="740" actId="1076"/>
+          <ac:picMkLst>
+            <pc:docMk/>
+            <pc:sldMk cId="3782647756" sldId="258"/>
+            <ac:picMk id="8" creationId="{49C1C1E0-7E67-E50E-7B59-7FA09F9139E9}"/>
+          </ac:picMkLst>
+        </pc:picChg>
+        <pc:picChg chg="add mod">
+          <ac:chgData name="Mathew Scaria" userId="3974405e373567ab" providerId="LiveId" clId="{2DD90D6B-2F61-4982-A7A9-64CA15CE61DE}" dt="2026-05-12T09:12:47.631" v="748" actId="1076"/>
+          <ac:picMkLst>
+            <pc:docMk/>
+            <pc:sldMk cId="3782647756" sldId="258"/>
+            <ac:picMk id="12" creationId="{07F84D41-0128-4E91-DF7E-E684BCFC94B7}"/>
+          </ac:picMkLst>
+        </pc:picChg>
+      </pc:sldChg>
+      <pc:sldChg chg="addSp delSp modSp add mod setBg">
+        <pc:chgData name="Mathew Scaria" userId="3974405e373567ab" providerId="LiveId" clId="{2DD90D6B-2F61-4982-A7A9-64CA15CE61DE}" dt="2026-05-12T08:56:07.555" v="699" actId="26606"/>
+        <pc:sldMkLst>
+          <pc:docMk/>
+          <pc:sldMk cId="3834200546" sldId="259"/>
+        </pc:sldMkLst>
+        <pc:spChg chg="mod">
+          <ac:chgData name="Mathew Scaria" userId="3974405e373567ab" providerId="LiveId" clId="{2DD90D6B-2F61-4982-A7A9-64CA15CE61DE}" dt="2026-05-11T14:08:21.315" v="541" actId="26606"/>
+          <ac:spMkLst>
+            <pc:docMk/>
+            <pc:sldMk cId="3834200546" sldId="259"/>
+            <ac:spMk id="2" creationId="{BE75DB38-488B-73F3-D26D-1A009508A715}"/>
+          </ac:spMkLst>
+        </pc:spChg>
+        <pc:spChg chg="del mod">
+          <ac:chgData name="Mathew Scaria" userId="3974405e373567ab" providerId="LiveId" clId="{2DD90D6B-2F61-4982-A7A9-64CA15CE61DE}" dt="2026-05-11T12:52:43.670" v="533" actId="478"/>
+          <ac:spMkLst>
+            <pc:docMk/>
+            <pc:sldMk cId="3834200546" sldId="259"/>
+            <ac:spMk id="3" creationId="{15A17663-BBEE-E4F5-39F7-48DF959D3ECE}"/>
+          </ac:spMkLst>
+        </pc:spChg>
+        <pc:spChg chg="add del">
+          <ac:chgData name="Mathew Scaria" userId="3974405e373567ab" providerId="LiveId" clId="{2DD90D6B-2F61-4982-A7A9-64CA15CE61DE}" dt="2026-05-11T14:08:21.298" v="540" actId="26606"/>
+          <ac:spMkLst>
+            <pc:docMk/>
+            <pc:sldMk cId="3834200546" sldId="259"/>
+            <ac:spMk id="13" creationId="{F0087D53-9295-4463-AAE4-D5C626046E9F}"/>
+          </ac:spMkLst>
+        </pc:spChg>
+        <pc:spChg chg="add del">
+          <ac:chgData name="Mathew Scaria" userId="3974405e373567ab" providerId="LiveId" clId="{2DD90D6B-2F61-4982-A7A9-64CA15CE61DE}" dt="2026-05-11T14:08:21.298" v="540" actId="26606"/>
+          <ac:spMkLst>
+            <pc:docMk/>
+            <pc:sldMk cId="3834200546" sldId="259"/>
+            <ac:spMk id="15" creationId="{D6A9C53F-5F90-40A5-8C85-5412D39C8C68}"/>
+          </ac:spMkLst>
+        </pc:spChg>
+        <pc:spChg chg="add del">
+          <ac:chgData name="Mathew Scaria" userId="3974405e373567ab" providerId="LiveId" clId="{2DD90D6B-2F61-4982-A7A9-64CA15CE61DE}" dt="2026-05-12T08:56:07.555" v="699" actId="26606"/>
+          <ac:spMkLst>
+            <pc:docMk/>
+            <pc:sldMk cId="3834200546" sldId="259"/>
+            <ac:spMk id="17" creationId="{15F33878-D502-4FFA-8ACE-F2AECDB2A23F}"/>
+          </ac:spMkLst>
+        </pc:spChg>
+        <pc:spChg chg="add del">
+          <ac:chgData name="Mathew Scaria" userId="3974405e373567ab" providerId="LiveId" clId="{2DD90D6B-2F61-4982-A7A9-64CA15CE61DE}" dt="2026-05-12T08:56:07.555" v="699" actId="26606"/>
+          <ac:spMkLst>
+            <pc:docMk/>
+            <pc:sldMk cId="3834200546" sldId="259"/>
+            <ac:spMk id="18" creationId="{2151139A-886F-4B97-8815-729AD3831BBD}"/>
+          </ac:spMkLst>
+        </pc:spChg>
+        <pc:spChg chg="add del">
+          <ac:chgData name="Mathew Scaria" userId="3974405e373567ab" providerId="LiveId" clId="{2DD90D6B-2F61-4982-A7A9-64CA15CE61DE}" dt="2026-05-12T08:56:07.555" v="699" actId="26606"/>
+          <ac:spMkLst>
+            <pc:docMk/>
+            <pc:sldMk cId="3834200546" sldId="259"/>
+            <ac:spMk id="19" creationId="{D3539FEE-81D3-4406-802E-60B20B16F4F6}"/>
+          </ac:spMkLst>
+        </pc:spChg>
+        <pc:spChg chg="add del">
+          <ac:chgData name="Mathew Scaria" userId="3974405e373567ab" providerId="LiveId" clId="{2DD90D6B-2F61-4982-A7A9-64CA15CE61DE}" dt="2026-05-12T08:56:07.555" v="699" actId="26606"/>
+          <ac:spMkLst>
+            <pc:docMk/>
+            <pc:sldMk cId="3834200546" sldId="259"/>
+            <ac:spMk id="20" creationId="{AB5E08C4-8CDD-4623-A5B8-E998C6DEE3B7}"/>
+          </ac:spMkLst>
+        </pc:spChg>
+        <pc:spChg chg="add del">
+          <ac:chgData name="Mathew Scaria" userId="3974405e373567ab" providerId="LiveId" clId="{2DD90D6B-2F61-4982-A7A9-64CA15CE61DE}" dt="2026-05-12T08:56:07.555" v="699" actId="26606"/>
+          <ac:spMkLst>
+            <pc:docMk/>
+            <pc:sldMk cId="3834200546" sldId="259"/>
+            <ac:spMk id="21" creationId="{DC701763-729E-462F-A5A8-E0DEFEB1E2E4}"/>
+          </ac:spMkLst>
+        </pc:spChg>
+        <pc:spChg chg="add">
+          <ac:chgData name="Mathew Scaria" userId="3974405e373567ab" providerId="LiveId" clId="{2DD90D6B-2F61-4982-A7A9-64CA15CE61DE}" dt="2026-05-12T08:56:07.555" v="699" actId="26606"/>
+          <ac:spMkLst>
+            <pc:docMk/>
+            <pc:sldMk cId="3834200546" sldId="259"/>
+            <ac:spMk id="26" creationId="{2151139A-886F-4B97-8815-729AD3831BBD}"/>
+          </ac:spMkLst>
+        </pc:spChg>
+        <pc:spChg chg="add">
+          <ac:chgData name="Mathew Scaria" userId="3974405e373567ab" providerId="LiveId" clId="{2DD90D6B-2F61-4982-A7A9-64CA15CE61DE}" dt="2026-05-12T08:56:07.555" v="699" actId="26606"/>
+          <ac:spMkLst>
+            <pc:docMk/>
+            <pc:sldMk cId="3834200546" sldId="259"/>
+            <ac:spMk id="28" creationId="{AB5E08C4-8CDD-4623-A5B8-E998C6DEE3B7}"/>
+          </ac:spMkLst>
+        </pc:spChg>
+        <pc:spChg chg="add">
+          <ac:chgData name="Mathew Scaria" userId="3974405e373567ab" providerId="LiveId" clId="{2DD90D6B-2F61-4982-A7A9-64CA15CE61DE}" dt="2026-05-12T08:56:07.555" v="699" actId="26606"/>
+          <ac:spMkLst>
+            <pc:docMk/>
+            <pc:sldMk cId="3834200546" sldId="259"/>
+            <ac:spMk id="30" creationId="{15F33878-D502-4FFA-8ACE-F2AECDB2A23F}"/>
+          </ac:spMkLst>
+        </pc:spChg>
+        <pc:spChg chg="add">
+          <ac:chgData name="Mathew Scaria" userId="3974405e373567ab" providerId="LiveId" clId="{2DD90D6B-2F61-4982-A7A9-64CA15CE61DE}" dt="2026-05-12T08:56:07.555" v="699" actId="26606"/>
+          <ac:spMkLst>
+            <pc:docMk/>
+            <pc:sldMk cId="3834200546" sldId="259"/>
+            <ac:spMk id="32" creationId="{D3539FEE-81D3-4406-802E-60B20B16F4F6}"/>
+          </ac:spMkLst>
+        </pc:spChg>
+        <pc:spChg chg="add">
+          <ac:chgData name="Mathew Scaria" userId="3974405e373567ab" providerId="LiveId" clId="{2DD90D6B-2F61-4982-A7A9-64CA15CE61DE}" dt="2026-05-12T08:56:07.555" v="699" actId="26606"/>
+          <ac:spMkLst>
+            <pc:docMk/>
+            <pc:sldMk cId="3834200546" sldId="259"/>
+            <ac:spMk id="34" creationId="{DC701763-729E-462F-A5A8-E0DEFEB1E2E4}"/>
+          </ac:spMkLst>
+        </pc:spChg>
+        <pc:picChg chg="add mod">
+          <ac:chgData name="Mathew Scaria" userId="3974405e373567ab" providerId="LiveId" clId="{2DD90D6B-2F61-4982-A7A9-64CA15CE61DE}" dt="2026-05-12T08:56:04.836" v="698" actId="931"/>
+          <ac:picMkLst>
+            <pc:docMk/>
+            <pc:sldMk cId="3834200546" sldId="259"/>
+            <ac:picMk id="4" creationId="{B0018D8A-B6DE-A8E5-BFFA-2841FEC916A5}"/>
+          </ac:picMkLst>
+        </pc:picChg>
+        <pc:picChg chg="del">
+          <ac:chgData name="Mathew Scaria" userId="3974405e373567ab" providerId="LiveId" clId="{2DD90D6B-2F61-4982-A7A9-64CA15CE61DE}" dt="2026-05-11T12:52:45.598" v="534" actId="478"/>
+          <ac:picMkLst>
+            <pc:docMk/>
+            <pc:sldMk cId="3834200546" sldId="259"/>
+            <ac:picMk id="5" creationId="{C7E6E961-97E0-B87F-E354-FB21BCDDE796}"/>
+          </ac:picMkLst>
+        </pc:picChg>
+        <pc:picChg chg="add del mod ord">
+          <ac:chgData name="Mathew Scaria" userId="3974405e373567ab" providerId="LiveId" clId="{2DD90D6B-2F61-4982-A7A9-64CA15CE61DE}" dt="2026-05-12T08:55:08.855" v="697" actId="478"/>
+          <ac:picMkLst>
+            <pc:docMk/>
+            <pc:sldMk cId="3834200546" sldId="259"/>
+            <ac:picMk id="6" creationId="{B57E2F11-47FF-9A0E-1243-92E81B72C466}"/>
+          </ac:picMkLst>
+        </pc:picChg>
+        <pc:picChg chg="add mod">
+          <ac:chgData name="Mathew Scaria" userId="3974405e373567ab" providerId="LiveId" clId="{2DD90D6B-2F61-4982-A7A9-64CA15CE61DE}" dt="2026-05-12T08:56:04.836" v="698" actId="931"/>
+          <ac:picMkLst>
+            <pc:docMk/>
+            <pc:sldMk cId="3834200546" sldId="259"/>
+            <ac:picMk id="7" creationId="{0E97F157-548C-F1B7-7EE2-0D3669303996}"/>
+          </ac:picMkLst>
+        </pc:picChg>
+        <pc:picChg chg="add del mod">
+          <ac:chgData name="Mathew Scaria" userId="3974405e373567ab" providerId="LiveId" clId="{2DD90D6B-2F61-4982-A7A9-64CA15CE61DE}" dt="2026-05-12T08:55:07.222" v="696" actId="478"/>
+          <ac:picMkLst>
+            <pc:docMk/>
+            <pc:sldMk cId="3834200546" sldId="259"/>
+            <ac:picMk id="8" creationId="{27BF0A68-95D7-643D-6084-214549D18034}"/>
+          </ac:picMkLst>
+        </pc:picChg>
+      </pc:sldChg>
+      <pc:sldChg chg="addSp delSp modSp add mod ord">
+        <pc:chgData name="Mathew Scaria" userId="3974405e373567ab" providerId="LiveId" clId="{2DD90D6B-2F61-4982-A7A9-64CA15CE61DE}" dt="2026-05-12T10:36:23.533" v="839" actId="1076"/>
+        <pc:sldMkLst>
+          <pc:docMk/>
+          <pc:sldMk cId="2584793608" sldId="260"/>
+        </pc:sldMkLst>
+        <pc:spChg chg="mod">
+          <ac:chgData name="Mathew Scaria" userId="3974405e373567ab" providerId="LiveId" clId="{2DD90D6B-2F61-4982-A7A9-64CA15CE61DE}" dt="2026-05-11T14:08:49.315" v="552" actId="20577"/>
+          <ac:spMkLst>
+            <pc:docMk/>
+            <pc:sldMk cId="2584793608" sldId="260"/>
+            <ac:spMk id="2" creationId="{679DCA66-6BF2-99E5-687E-4AAD2DF651E6}"/>
+          </ac:spMkLst>
+        </pc:spChg>
+        <pc:spChg chg="del">
+          <ac:chgData name="Mathew Scaria" userId="3974405e373567ab" providerId="LiveId" clId="{2DD90D6B-2F61-4982-A7A9-64CA15CE61DE}" dt="2026-05-11T14:08:45.524" v="545" actId="478"/>
+          <ac:spMkLst>
+            <pc:docMk/>
+            <pc:sldMk cId="2584793608" sldId="260"/>
+            <ac:spMk id="3" creationId="{801F271E-DEBE-D5B7-A9DE-7F214B5BE560}"/>
+          </ac:spMkLst>
+        </pc:spChg>
+        <pc:picChg chg="add mod">
+          <ac:chgData name="Mathew Scaria" userId="3974405e373567ab" providerId="LiveId" clId="{2DD90D6B-2F61-4982-A7A9-64CA15CE61DE}" dt="2026-05-12T10:36:23.533" v="839" actId="1076"/>
+          <ac:picMkLst>
+            <pc:docMk/>
+            <pc:sldMk cId="2584793608" sldId="260"/>
+            <ac:picMk id="4" creationId="{889F8FA7-4039-DF79-D7AB-7B16A3CC7548}"/>
+          </ac:picMkLst>
+        </pc:picChg>
+      </pc:sldChg>
+      <pc:sldChg chg="addSp delSp modSp add mod setBg delDesignElem">
+        <pc:chgData name="Mathew Scaria" userId="3974405e373567ab" providerId="LiveId" clId="{2DD90D6B-2F61-4982-A7A9-64CA15CE61DE}" dt="2026-05-12T09:33:20.893" v="773" actId="14100"/>
+        <pc:sldMkLst>
+          <pc:docMk/>
+          <pc:sldMk cId="1978823791" sldId="261"/>
+        </pc:sldMkLst>
+        <pc:spChg chg="del">
+          <ac:chgData name="Mathew Scaria" userId="3974405e373567ab" providerId="LiveId" clId="{2DD90D6B-2F61-4982-A7A9-64CA15CE61DE}" dt="2026-05-12T09:20:42.718" v="756"/>
+          <ac:spMkLst>
+            <pc:docMk/>
+            <pc:sldMk cId="1978823791" sldId="261"/>
+            <ac:spMk id="26" creationId="{F84C3A42-BC77-26EB-FA5F-2A0DBC9F02AF}"/>
+          </ac:spMkLst>
+        </pc:spChg>
+        <pc:spChg chg="del">
+          <ac:chgData name="Mathew Scaria" userId="3974405e373567ab" providerId="LiveId" clId="{2DD90D6B-2F61-4982-A7A9-64CA15CE61DE}" dt="2026-05-12T09:20:42.718" v="756"/>
+          <ac:spMkLst>
+            <pc:docMk/>
+            <pc:sldMk cId="1978823791" sldId="261"/>
+            <ac:spMk id="28" creationId="{F8860349-75C4-8FAD-5FF8-AE751FD48F71}"/>
+          </ac:spMkLst>
+        </pc:spChg>
+        <pc:spChg chg="del">
+          <ac:chgData name="Mathew Scaria" userId="3974405e373567ab" providerId="LiveId" clId="{2DD90D6B-2F61-4982-A7A9-64CA15CE61DE}" dt="2026-05-12T09:20:42.718" v="756"/>
+          <ac:spMkLst>
+            <pc:docMk/>
+            <pc:sldMk cId="1978823791" sldId="261"/>
+            <ac:spMk id="30" creationId="{5F944EEB-9C49-652E-4A9D-D2277E36C8CB}"/>
+          </ac:spMkLst>
+        </pc:spChg>
+        <pc:spChg chg="del">
+          <ac:chgData name="Mathew Scaria" userId="3974405e373567ab" providerId="LiveId" clId="{2DD90D6B-2F61-4982-A7A9-64CA15CE61DE}" dt="2026-05-12T09:20:42.718" v="756"/>
+          <ac:spMkLst>
+            <pc:docMk/>
+            <pc:sldMk cId="1978823791" sldId="261"/>
+            <ac:spMk id="32" creationId="{033D739E-3541-A572-0535-418D1362E467}"/>
+          </ac:spMkLst>
+        </pc:spChg>
+        <pc:spChg chg="del">
+          <ac:chgData name="Mathew Scaria" userId="3974405e373567ab" providerId="LiveId" clId="{2DD90D6B-2F61-4982-A7A9-64CA15CE61DE}" dt="2026-05-12T09:20:42.718" v="756"/>
+          <ac:spMkLst>
+            <pc:docMk/>
+            <pc:sldMk cId="1978823791" sldId="261"/>
+            <ac:spMk id="34" creationId="{7F59BD1C-B847-10EE-A4AF-C108B5C24B49}"/>
+          </ac:spMkLst>
+        </pc:spChg>
+        <pc:picChg chg="mod">
+          <ac:chgData name="Mathew Scaria" userId="3974405e373567ab" providerId="LiveId" clId="{2DD90D6B-2F61-4982-A7A9-64CA15CE61DE}" dt="2026-05-12T09:29:36.921" v="766" actId="1076"/>
+          <ac:picMkLst>
+            <pc:docMk/>
+            <pc:sldMk cId="1978823791" sldId="261"/>
+            <ac:picMk id="4" creationId="{09884374-A222-D04E-EE99-43CF9877F22B}"/>
+          </ac:picMkLst>
+        </pc:picChg>
+        <pc:picChg chg="add mod">
+          <ac:chgData name="Mathew Scaria" userId="3974405e373567ab" providerId="LiveId" clId="{2DD90D6B-2F61-4982-A7A9-64CA15CE61DE}" dt="2026-05-12T09:29:56.313" v="770" actId="14100"/>
+          <ac:picMkLst>
+            <pc:docMk/>
+            <pc:sldMk cId="1978823791" sldId="261"/>
+            <ac:picMk id="5" creationId="{C27B7B12-1A2F-23FF-5072-D0B062433574}"/>
+          </ac:picMkLst>
+        </pc:picChg>
+        <pc:picChg chg="mod">
+          <ac:chgData name="Mathew Scaria" userId="3974405e373567ab" providerId="LiveId" clId="{2DD90D6B-2F61-4982-A7A9-64CA15CE61DE}" dt="2026-05-12T09:29:39.790" v="767" actId="1076"/>
+          <ac:picMkLst>
+            <pc:docMk/>
+            <pc:sldMk cId="1978823791" sldId="261"/>
+            <ac:picMk id="7" creationId="{DC89EEB7-5692-EFBF-5FD1-7357A9E5CAD9}"/>
+          </ac:picMkLst>
+        </pc:picChg>
+        <pc:picChg chg="add mod">
+          <ac:chgData name="Mathew Scaria" userId="3974405e373567ab" providerId="LiveId" clId="{2DD90D6B-2F61-4982-A7A9-64CA15CE61DE}" dt="2026-05-12T09:33:20.893" v="773" actId="14100"/>
+          <ac:picMkLst>
+            <pc:docMk/>
+            <pc:sldMk cId="1978823791" sldId="261"/>
+            <ac:picMk id="8" creationId="{4111B534-E254-90E2-81A4-B5D259190848}"/>
+          </ac:picMkLst>
+        </pc:picChg>
+      </pc:sldChg>
+      <pc:sldChg chg="addSp delSp modSp add mod">
+        <pc:chgData name="Mathew Scaria" userId="3974405e373567ab" providerId="LiveId" clId="{2DD90D6B-2F61-4982-A7A9-64CA15CE61DE}" dt="2026-05-12T10:13:54.211" v="804" actId="1076"/>
+        <pc:sldMkLst>
+          <pc:docMk/>
+          <pc:sldMk cId="2786174565" sldId="262"/>
+        </pc:sldMkLst>
+        <pc:spChg chg="del">
+          <ac:chgData name="Mathew Scaria" userId="3974405e373567ab" providerId="LiveId" clId="{2DD90D6B-2F61-4982-A7A9-64CA15CE61DE}" dt="2026-05-12T10:04:15.772" v="797" actId="478"/>
+          <ac:spMkLst>
+            <pc:docMk/>
+            <pc:sldMk cId="2786174565" sldId="262"/>
+            <ac:spMk id="2" creationId="{97CACD35-41A9-3447-14DA-7BD49C438A68}"/>
+          </ac:spMkLst>
+        </pc:spChg>
+        <pc:spChg chg="del">
+          <ac:chgData name="Mathew Scaria" userId="3974405e373567ab" providerId="LiveId" clId="{2DD90D6B-2F61-4982-A7A9-64CA15CE61DE}" dt="2026-05-12T10:04:06.400" v="794" actId="478"/>
+          <ac:spMkLst>
+            <pc:docMk/>
+            <pc:sldMk cId="2786174565" sldId="262"/>
+            <ac:spMk id="3" creationId="{0F40D0D2-3C59-96D9-08D5-56C747DA33D9}"/>
+          </ac:spMkLst>
+        </pc:spChg>
+        <pc:spChg chg="add del mod">
+          <ac:chgData name="Mathew Scaria" userId="3974405e373567ab" providerId="LiveId" clId="{2DD90D6B-2F61-4982-A7A9-64CA15CE61DE}" dt="2026-05-12T10:04:21.750" v="798" actId="478"/>
+          <ac:spMkLst>
+            <pc:docMk/>
+            <pc:sldMk cId="2786174565" sldId="262"/>
+            <ac:spMk id="5" creationId="{D6958EF7-3E5C-5E66-E8E6-91E2891958FE}"/>
+          </ac:spMkLst>
+        </pc:spChg>
+        <pc:picChg chg="add mod">
+          <ac:chgData name="Mathew Scaria" userId="3974405e373567ab" providerId="LiveId" clId="{2DD90D6B-2F61-4982-A7A9-64CA15CE61DE}" dt="2026-05-12T10:13:54.211" v="804" actId="1076"/>
+          <ac:picMkLst>
+            <pc:docMk/>
+            <pc:sldMk cId="2786174565" sldId="262"/>
+            <ac:picMk id="7" creationId="{C5386D65-95D1-50E3-BA41-45A20A609B67}"/>
+          </ac:picMkLst>
+        </pc:picChg>
+        <pc:picChg chg="del">
+          <ac:chgData name="Mathew Scaria" userId="3974405e373567ab" providerId="LiveId" clId="{2DD90D6B-2F61-4982-A7A9-64CA15CE61DE}" dt="2026-05-12T10:04:08.376" v="795" actId="478"/>
+          <ac:picMkLst>
+            <pc:docMk/>
+            <pc:sldMk cId="2786174565" sldId="262"/>
+            <ac:picMk id="8" creationId="{94BCDB74-3EC7-292E-25AD-9A290DCFCD89}"/>
+          </ac:picMkLst>
+        </pc:picChg>
+        <pc:picChg chg="del">
+          <ac:chgData name="Mathew Scaria" userId="3974405e373567ab" providerId="LiveId" clId="{2DD90D6B-2F61-4982-A7A9-64CA15CE61DE}" dt="2026-05-12T10:04:09.892" v="796" actId="478"/>
+          <ac:picMkLst>
+            <pc:docMk/>
+            <pc:sldMk cId="2786174565" sldId="262"/>
+            <ac:picMk id="12" creationId="{F28725D8-66DC-3A69-7DFF-6EEFBC989FD4}"/>
+          </ac:picMkLst>
+        </pc:picChg>
+      </pc:sldChg>
+      <pc:sldChg chg="addSp delSp modSp add mod">
+        <pc:chgData name="Mathew Scaria" userId="3974405e373567ab" providerId="LiveId" clId="{2DD90D6B-2F61-4982-A7A9-64CA15CE61DE}" dt="2026-05-12T10:16:09.297" v="812" actId="1076"/>
+        <pc:sldMkLst>
+          <pc:docMk/>
+          <pc:sldMk cId="1629346611" sldId="263"/>
+        </pc:sldMkLst>
+        <pc:picChg chg="add mod">
+          <ac:chgData name="Mathew Scaria" userId="3974405e373567ab" providerId="LiveId" clId="{2DD90D6B-2F61-4982-A7A9-64CA15CE61DE}" dt="2026-05-12T10:16:09.297" v="812" actId="1076"/>
+          <ac:picMkLst>
+            <pc:docMk/>
+            <pc:sldMk cId="1629346611" sldId="263"/>
+            <ac:picMk id="3" creationId="{15D04751-230A-CF97-A233-D2E7B937977B}"/>
+          </ac:picMkLst>
+        </pc:picChg>
+        <pc:picChg chg="del">
+          <ac:chgData name="Mathew Scaria" userId="3974405e373567ab" providerId="LiveId" clId="{2DD90D6B-2F61-4982-A7A9-64CA15CE61DE}" dt="2026-05-12T10:15:25.573" v="806" actId="478"/>
+          <ac:picMkLst>
+            <pc:docMk/>
+            <pc:sldMk cId="1629346611" sldId="263"/>
+            <ac:picMk id="7" creationId="{99DB04A4-3BBC-2A08-483F-AF1800A32EC6}"/>
+          </ac:picMkLst>
+        </pc:picChg>
+      </pc:sldChg>
+      <pc:sldChg chg="addSp delSp modSp add mod">
+        <pc:chgData name="Mathew Scaria" userId="3974405e373567ab" providerId="LiveId" clId="{2DD90D6B-2F61-4982-A7A9-64CA15CE61DE}" dt="2026-05-12T10:25:28.020" v="823" actId="1076"/>
+        <pc:sldMkLst>
+          <pc:docMk/>
+          <pc:sldMk cId="306443379" sldId="264"/>
+        </pc:sldMkLst>
+        <pc:picChg chg="del">
+          <ac:chgData name="Mathew Scaria" userId="3974405e373567ab" providerId="LiveId" clId="{2DD90D6B-2F61-4982-A7A9-64CA15CE61DE}" dt="2026-05-12T10:19:51.683" v="814" actId="478"/>
+          <ac:picMkLst>
+            <pc:docMk/>
+            <pc:sldMk cId="306443379" sldId="264"/>
+            <ac:picMk id="3" creationId="{F2EE205B-7019-757F-78D9-D0C23B49C54C}"/>
+          </ac:picMkLst>
+        </pc:picChg>
+        <pc:picChg chg="add del mod">
+          <ac:chgData name="Mathew Scaria" userId="3974405e373567ab" providerId="LiveId" clId="{2DD90D6B-2F61-4982-A7A9-64CA15CE61DE}" dt="2026-05-12T10:25:10.931" v="819" actId="478"/>
+          <ac:picMkLst>
+            <pc:docMk/>
+            <pc:sldMk cId="306443379" sldId="264"/>
+            <ac:picMk id="4" creationId="{C6A1B9CC-5E52-2509-44DE-43109AFB5D7D}"/>
+          </ac:picMkLst>
+        </pc:picChg>
+        <pc:picChg chg="add mod">
+          <ac:chgData name="Mathew Scaria" userId="3974405e373567ab" providerId="LiveId" clId="{2DD90D6B-2F61-4982-A7A9-64CA15CE61DE}" dt="2026-05-12T10:25:28.020" v="823" actId="1076"/>
+          <ac:picMkLst>
+            <pc:docMk/>
+            <pc:sldMk cId="306443379" sldId="264"/>
+            <ac:picMk id="6" creationId="{78FD8723-8AFB-BA0C-FC26-76D066F26F87}"/>
+          </ac:picMkLst>
+        </pc:picChg>
+      </pc:sldChg>
+      <pc:sldChg chg="addSp delSp modSp add mod">
+        <pc:chgData name="Mathew Scaria" userId="3974405e373567ab" providerId="LiveId" clId="{2DD90D6B-2F61-4982-A7A9-64CA15CE61DE}" dt="2026-05-12T10:28:38.203" v="835" actId="1076"/>
+        <pc:sldMkLst>
+          <pc:docMk/>
+          <pc:sldMk cId="458643595" sldId="265"/>
+        </pc:sldMkLst>
+        <pc:picChg chg="add mod">
+          <ac:chgData name="Mathew Scaria" userId="3974405e373567ab" providerId="LiveId" clId="{2DD90D6B-2F61-4982-A7A9-64CA15CE61DE}" dt="2026-05-12T10:27:51.088" v="829" actId="1076"/>
+          <ac:picMkLst>
+            <pc:docMk/>
+            <pc:sldMk cId="458643595" sldId="265"/>
+            <ac:picMk id="3" creationId="{81D147DD-B0F0-53B5-F086-BC0AB68D7E2D}"/>
+          </ac:picMkLst>
+        </pc:picChg>
+        <pc:picChg chg="add mod">
+          <ac:chgData name="Mathew Scaria" userId="3974405e373567ab" providerId="LiveId" clId="{2DD90D6B-2F61-4982-A7A9-64CA15CE61DE}" dt="2026-05-12T10:28:38.203" v="835" actId="1076"/>
+          <ac:picMkLst>
+            <pc:docMk/>
+            <pc:sldMk cId="458643595" sldId="265"/>
+            <ac:picMk id="5" creationId="{92628A3A-4152-5254-973B-26AC7464DCC0}"/>
+          </ac:picMkLst>
+        </pc:picChg>
+        <pc:picChg chg="del">
+          <ac:chgData name="Mathew Scaria" userId="3974405e373567ab" providerId="LiveId" clId="{2DD90D6B-2F61-4982-A7A9-64CA15CE61DE}" dt="2026-05-12T10:26:50.440" v="825" actId="478"/>
+          <ac:picMkLst>
+            <pc:docMk/>
+            <pc:sldMk cId="458643595" sldId="265"/>
+            <ac:picMk id="6" creationId="{1968020A-6A21-2342-BA84-D4E6F04B7486}"/>
+          </ac:picMkLst>
+        </pc:picChg>
+      </pc:sldChg>
     </pc:docChg>
   </pc:docChgLst>
 </pc:chgInfo>
@@ -291,7 +824,7 @@
           <a:p>
             <a:fld id="{6A8FE864-9043-4F46-A474-21228CF5E085}" type="datetimeFigureOut">
               <a:rPr lang="en-US" smtClean="0"/>
-              <a:t>5/8/2026</a:t>
+              <a:t>5/11/2026</a:t>
             </a:fld>
             <a:endParaRPr lang="en-US"/>
           </a:p>
@@ -489,7 +1022,7 @@
           <a:p>
             <a:fld id="{6A8FE864-9043-4F46-A474-21228CF5E085}" type="datetimeFigureOut">
               <a:rPr lang="en-US" smtClean="0"/>
-              <a:t>5/8/2026</a:t>
+              <a:t>5/11/2026</a:t>
             </a:fld>
             <a:endParaRPr lang="en-US"/>
           </a:p>
@@ -697,7 +1230,7 @@
           <a:p>
             <a:fld id="{6A8FE864-9043-4F46-A474-21228CF5E085}" type="datetimeFigureOut">
               <a:rPr lang="en-US" smtClean="0"/>
-              <a:t>5/8/2026</a:t>
+              <a:t>5/11/2026</a:t>
             </a:fld>
             <a:endParaRPr lang="en-US"/>
           </a:p>
@@ -895,7 +1428,7 @@
           <a:p>
             <a:fld id="{6A8FE864-9043-4F46-A474-21228CF5E085}" type="datetimeFigureOut">
               <a:rPr lang="en-US" smtClean="0"/>
-              <a:t>5/8/2026</a:t>
+              <a:t>5/11/2026</a:t>
             </a:fld>
             <a:endParaRPr lang="en-US"/>
           </a:p>
@@ -1170,7 +1703,7 @@
           <a:p>
             <a:fld id="{6A8FE864-9043-4F46-A474-21228CF5E085}" type="datetimeFigureOut">
               <a:rPr lang="en-US" smtClean="0"/>
-              <a:t>5/8/2026</a:t>
+              <a:t>5/11/2026</a:t>
             </a:fld>
             <a:endParaRPr lang="en-US"/>
           </a:p>
@@ -1435,7 +1968,7 @@
           <a:p>
             <a:fld id="{6A8FE864-9043-4F46-A474-21228CF5E085}" type="datetimeFigureOut">
               <a:rPr lang="en-US" smtClean="0"/>
-              <a:t>5/8/2026</a:t>
+              <a:t>5/11/2026</a:t>
             </a:fld>
             <a:endParaRPr lang="en-US"/>
           </a:p>
@@ -1847,7 +2380,7 @@
           <a:p>
             <a:fld id="{6A8FE864-9043-4F46-A474-21228CF5E085}" type="datetimeFigureOut">
               <a:rPr lang="en-US" smtClean="0"/>
-              <a:t>5/8/2026</a:t>
+              <a:t>5/11/2026</a:t>
             </a:fld>
             <a:endParaRPr lang="en-US"/>
           </a:p>
@@ -1988,7 +2521,7 @@
           <a:p>
             <a:fld id="{6A8FE864-9043-4F46-A474-21228CF5E085}" type="datetimeFigureOut">
               <a:rPr lang="en-US" smtClean="0"/>
-              <a:t>5/8/2026</a:t>
+              <a:t>5/11/2026</a:t>
             </a:fld>
             <a:endParaRPr lang="en-US"/>
           </a:p>
@@ -2101,7 +2634,7 @@
           <a:p>
             <a:fld id="{6A8FE864-9043-4F46-A474-21228CF5E085}" type="datetimeFigureOut">
               <a:rPr lang="en-US" smtClean="0"/>
-              <a:t>5/8/2026</a:t>
+              <a:t>5/11/2026</a:t>
             </a:fld>
             <a:endParaRPr lang="en-US"/>
           </a:p>
@@ -2412,7 +2945,7 @@
           <a:p>
             <a:fld id="{6A8FE864-9043-4F46-A474-21228CF5E085}" type="datetimeFigureOut">
               <a:rPr lang="en-US" smtClean="0"/>
-              <a:t>5/8/2026</a:t>
+              <a:t>5/11/2026</a:t>
             </a:fld>
             <a:endParaRPr lang="en-US"/>
           </a:p>
@@ -2700,7 +3233,7 @@
           <a:p>
             <a:fld id="{6A8FE864-9043-4F46-A474-21228CF5E085}" type="datetimeFigureOut">
               <a:rPr lang="en-US" smtClean="0"/>
-              <a:t>5/8/2026</a:t>
+              <a:t>5/11/2026</a:t>
             </a:fld>
             <a:endParaRPr lang="en-US"/>
           </a:p>
@@ -2941,7 +3474,7 @@
           <a:p>
             <a:fld id="{6A8FE864-9043-4F46-A474-21228CF5E085}" type="datetimeFigureOut">
               <a:rPr lang="en-US" smtClean="0"/>
-              <a:t>5/8/2026</a:t>
+              <a:t>5/11/2026</a:t>
             </a:fld>
             <a:endParaRPr lang="en-US"/>
           </a:p>
@@ -3418,6 +3951,1775 @@
     <p:extLst>
       <p:ext uri="{BB962C8B-B14F-4D97-AF65-F5344CB8AC3E}">
         <p14:creationId xmlns:p14="http://schemas.microsoft.com/office/powerpoint/2010/main" val="2987522229"/>
+      </p:ext>
+    </p:extLst>
+  </p:cSld>
+  <p:clrMapOvr>
+    <a:masterClrMapping/>
+  </p:clrMapOvr>
+</p:sld>
+</file>
+
+<file path=ppt/slides/slide10.xml><?xml version="1.0" encoding="utf-8"?>
+<p:sld xmlns:a="http://schemas.openxmlformats.org/drawingml/2006/main" xmlns:r="http://schemas.openxmlformats.org/officeDocument/2006/relationships" xmlns:p="http://schemas.openxmlformats.org/presentationml/2006/main">
+  <p:cSld>
+    <p:spTree>
+      <p:nvGrpSpPr>
+        <p:cNvPr id="1" name="">
+          <a:extLst>
+            <a:ext uri="{FF2B5EF4-FFF2-40B4-BE49-F238E27FC236}">
+              <a16:creationId xmlns:a16="http://schemas.microsoft.com/office/drawing/2014/main" id="{1CD1BE3A-BB6E-9ED9-6305-7198B67660FA}"/>
+            </a:ext>
+          </a:extLst>
+        </p:cNvPr>
+        <p:cNvGrpSpPr/>
+        <p:nvPr/>
+      </p:nvGrpSpPr>
+      <p:grpSpPr>
+        <a:xfrm>
+          <a:off x="0" y="0"/>
+          <a:ext cx="0" cy="0"/>
+          <a:chOff x="0" y="0"/>
+          <a:chExt cx="0" cy="0"/>
+        </a:xfrm>
+      </p:grpSpPr>
+      <p:sp>
+        <p:nvSpPr>
+          <p:cNvPr id="2" name="Title 1">
+            <a:extLst>
+              <a:ext uri="{FF2B5EF4-FFF2-40B4-BE49-F238E27FC236}">
+                <a16:creationId xmlns:a16="http://schemas.microsoft.com/office/drawing/2014/main" id="{679DCA66-6BF2-99E5-687E-4AAD2DF651E6}"/>
+              </a:ext>
+            </a:extLst>
+          </p:cNvPr>
+          <p:cNvSpPr>
+            <a:spLocks noGrp="1"/>
+          </p:cNvSpPr>
+          <p:nvPr>
+            <p:ph type="title"/>
+          </p:nvPr>
+        </p:nvSpPr>
+        <p:spPr/>
+        <p:txBody>
+          <a:bodyPr/>
+          <a:lstStyle/>
+          <a:p>
+            <a:r>
+              <a:rPr lang="en-US" dirty="0"/>
+              <a:t>Results</a:t>
+            </a:r>
+          </a:p>
+        </p:txBody>
+      </p:sp>
+      <p:pic>
+        <p:nvPicPr>
+          <p:cNvPr id="4" name="Picture 3">
+            <a:extLst>
+              <a:ext uri="{FF2B5EF4-FFF2-40B4-BE49-F238E27FC236}">
+                <a16:creationId xmlns:a16="http://schemas.microsoft.com/office/drawing/2014/main" id="{889F8FA7-4039-DF79-D7AB-7B16A3CC7548}"/>
+              </a:ext>
+            </a:extLst>
+          </p:cNvPr>
+          <p:cNvPicPr>
+            <a:picLocks noChangeAspect="1"/>
+          </p:cNvPicPr>
+          <p:nvPr/>
+        </p:nvPicPr>
+        <p:blipFill>
+          <a:blip r:embed="rId2">
+            <a:extLst>
+              <a:ext uri="{28A0092B-C50C-407E-A947-70E740481C1C}">
+                <a14:useLocalDpi xmlns:a14="http://schemas.microsoft.com/office/drawing/2010/main" val="0"/>
+              </a:ext>
+            </a:extLst>
+          </a:blip>
+          <a:stretch>
+            <a:fillRect/>
+          </a:stretch>
+        </p:blipFill>
+        <p:spPr>
+          <a:xfrm>
+            <a:off x="2888388" y="1442029"/>
+            <a:ext cx="6415223" cy="4873442"/>
+          </a:xfrm>
+          <a:prstGeom prst="rect">
+            <a:avLst/>
+          </a:prstGeom>
+        </p:spPr>
+      </p:pic>
+    </p:spTree>
+    <p:extLst>
+      <p:ext uri="{BB962C8B-B14F-4D97-AF65-F5344CB8AC3E}">
+        <p14:creationId xmlns:p14="http://schemas.microsoft.com/office/powerpoint/2010/main" val="2584793608"/>
+      </p:ext>
+    </p:extLst>
+  </p:cSld>
+  <p:clrMapOvr>
+    <a:masterClrMapping/>
+  </p:clrMapOvr>
+</p:sld>
+</file>
+
+<file path=ppt/slides/slide2.xml><?xml version="1.0" encoding="utf-8"?>
+<p:sld xmlns:a="http://schemas.openxmlformats.org/drawingml/2006/main" xmlns:r="http://schemas.openxmlformats.org/officeDocument/2006/relationships" xmlns:p="http://schemas.openxmlformats.org/presentationml/2006/main">
+  <p:cSld>
+    <p:spTree>
+      <p:nvGrpSpPr>
+        <p:cNvPr id="1" name=""/>
+        <p:cNvGrpSpPr/>
+        <p:nvPr/>
+      </p:nvGrpSpPr>
+      <p:grpSpPr>
+        <a:xfrm>
+          <a:off x="0" y="0"/>
+          <a:ext cx="0" cy="0"/>
+          <a:chOff x="0" y="0"/>
+          <a:chExt cx="0" cy="0"/>
+        </a:xfrm>
+      </p:grpSpPr>
+      <p:sp>
+        <p:nvSpPr>
+          <p:cNvPr id="2" name="Title 1">
+            <a:extLst>
+              <a:ext uri="{FF2B5EF4-FFF2-40B4-BE49-F238E27FC236}">
+                <a16:creationId xmlns:a16="http://schemas.microsoft.com/office/drawing/2014/main" id="{8029751E-C0FC-5E6E-2304-5276104486F3}"/>
+              </a:ext>
+            </a:extLst>
+          </p:cNvPr>
+          <p:cNvSpPr>
+            <a:spLocks noGrp="1"/>
+          </p:cNvSpPr>
+          <p:nvPr>
+            <p:ph type="title"/>
+          </p:nvPr>
+        </p:nvSpPr>
+        <p:spPr/>
+        <p:txBody>
+          <a:bodyPr/>
+          <a:lstStyle/>
+          <a:p>
+            <a:r>
+              <a:rPr lang="en-US" dirty="0"/>
+              <a:t>Intro</a:t>
+            </a:r>
+          </a:p>
+        </p:txBody>
+      </p:sp>
+      <p:sp>
+        <p:nvSpPr>
+          <p:cNvPr id="3" name="TextBox 2">
+            <a:extLst>
+              <a:ext uri="{FF2B5EF4-FFF2-40B4-BE49-F238E27FC236}">
+                <a16:creationId xmlns:a16="http://schemas.microsoft.com/office/drawing/2014/main" id="{9FDB1765-415D-8A50-0123-6B10E598B749}"/>
+              </a:ext>
+            </a:extLst>
+          </p:cNvPr>
+          <p:cNvSpPr txBox="1"/>
+          <p:nvPr/>
+        </p:nvSpPr>
+        <p:spPr>
+          <a:xfrm>
+            <a:off x="838200" y="1690687"/>
+            <a:ext cx="10439400" cy="4524315"/>
+          </a:xfrm>
+          <a:prstGeom prst="rect">
+            <a:avLst/>
+          </a:prstGeom>
+          <a:noFill/>
+        </p:spPr>
+        <p:txBody>
+          <a:bodyPr wrap="square" rtlCol="0">
+            <a:spAutoFit/>
+          </a:bodyPr>
+          <a:lstStyle/>
+          <a:p>
+            <a:r>
+              <a:rPr lang="en-US" b="1" dirty="0"/>
+              <a:t>Research Question:</a:t>
+            </a:r>
+            <a:r>
+              <a:rPr lang="en-US" dirty="0"/>
+              <a:t> How do Vacancy Rates Affect Fair Market Rent?</a:t>
+            </a:r>
+            <a:br>
+              <a:rPr lang="en-US" dirty="0"/>
+            </a:br>
+            <a:endParaRPr lang="en-US" dirty="0"/>
+          </a:p>
+          <a:p>
+            <a:r>
+              <a:rPr lang="en-US" b="1" dirty="0"/>
+              <a:t>Hypothesis: </a:t>
+            </a:r>
+            <a:r>
+              <a:rPr lang="en-US" dirty="0"/>
+              <a:t>Low vacancy rate leads to higher rent and high vacancy rate leads to low rent</a:t>
+            </a:r>
+            <a:endParaRPr lang="en-US" b="1" dirty="0"/>
+          </a:p>
+          <a:p>
+            <a:endParaRPr lang="en-US" b="1" dirty="0"/>
+          </a:p>
+          <a:p>
+            <a:r>
+              <a:rPr lang="en-US" b="1" dirty="0"/>
+              <a:t>Dependent Variable:</a:t>
+            </a:r>
+            <a:r>
+              <a:rPr lang="en-US" dirty="0"/>
+              <a:t> fmr_2bed (Fair Market Rent for a 2-bedroom unit)</a:t>
+            </a:r>
+            <a:br>
+              <a:rPr lang="en-US" dirty="0"/>
+            </a:br>
+            <a:endParaRPr lang="en-US" dirty="0"/>
+          </a:p>
+          <a:p>
+            <a:r>
+              <a:rPr lang="en-US" b="1" dirty="0"/>
+              <a:t>Independent Variable:</a:t>
+            </a:r>
+            <a:r>
+              <a:rPr lang="en-US" dirty="0"/>
+              <a:t> vacancy_rate (The percent of all housing units in a county that are vacant)</a:t>
+            </a:r>
+            <a:br>
+              <a:rPr lang="en-US" dirty="0"/>
+            </a:br>
+            <a:endParaRPr lang="en-US" dirty="0"/>
+          </a:p>
+          <a:p>
+            <a:endParaRPr lang="en-US" dirty="0"/>
+          </a:p>
+          <a:p>
+            <a:endParaRPr lang="en-US" dirty="0"/>
+          </a:p>
+          <a:p>
+            <a:endParaRPr lang="en-US" dirty="0"/>
+          </a:p>
+          <a:p>
+            <a:r>
+              <a:rPr lang="en-US" b="1" dirty="0"/>
+              <a:t>Controls:</a:t>
+            </a:r>
+            <a:br>
+              <a:rPr lang="en-US" dirty="0"/>
+            </a:br>
+            <a:r>
+              <a:rPr lang="en-US" dirty="0" err="1"/>
+              <a:t>total_housing_units</a:t>
+            </a:r>
+            <a:r>
+              <a:rPr lang="en-US" dirty="0"/>
+              <a:t> (Total number of housing units in a county, including apartments, houses, and all other unit types)</a:t>
+            </a:r>
+            <a:br>
+              <a:rPr lang="en-US" dirty="0"/>
+            </a:br>
+            <a:r>
+              <a:rPr lang="en-US" dirty="0" err="1"/>
+              <a:t>median_income</a:t>
+            </a:r>
+            <a:r>
+              <a:rPr lang="en-US" dirty="0"/>
+              <a:t> (Median household income in dollars)</a:t>
+            </a:r>
+            <a:br>
+              <a:rPr lang="en-US" dirty="0"/>
+            </a:br>
+            <a:r>
+              <a:rPr lang="en-US" dirty="0" err="1"/>
+              <a:t>households_with_children</a:t>
+            </a:r>
+            <a:r>
+              <a:rPr lang="en-US" dirty="0"/>
+              <a:t> (The number of families with children under 18)</a:t>
+            </a:r>
+          </a:p>
+        </p:txBody>
+      </p:sp>
+      <p:pic>
+        <p:nvPicPr>
+          <p:cNvPr id="5" name="Picture 4">
+            <a:extLst>
+              <a:ext uri="{FF2B5EF4-FFF2-40B4-BE49-F238E27FC236}">
+                <a16:creationId xmlns:a16="http://schemas.microsoft.com/office/drawing/2014/main" id="{E7A385A5-044D-9747-7FF8-1819C7CE0755}"/>
+              </a:ext>
+            </a:extLst>
+          </p:cNvPr>
+          <p:cNvPicPr>
+            <a:picLocks noChangeAspect="1"/>
+          </p:cNvPicPr>
+          <p:nvPr/>
+        </p:nvPicPr>
+        <p:blipFill>
+          <a:blip r:embed="rId2">
+            <a:extLst>
+              <a:ext uri="{28A0092B-C50C-407E-A947-70E740481C1C}">
+                <a14:useLocalDpi xmlns:a14="http://schemas.microsoft.com/office/drawing/2010/main" val="0"/>
+              </a:ext>
+            </a:extLst>
+          </a:blip>
+          <a:stretch>
+            <a:fillRect/>
+          </a:stretch>
+        </p:blipFill>
+        <p:spPr>
+          <a:xfrm>
+            <a:off x="914400" y="3715352"/>
+            <a:ext cx="10108812" cy="949349"/>
+          </a:xfrm>
+          <a:prstGeom prst="rect">
+            <a:avLst/>
+          </a:prstGeom>
+        </p:spPr>
+      </p:pic>
+    </p:spTree>
+    <p:extLst>
+      <p:ext uri="{BB962C8B-B14F-4D97-AF65-F5344CB8AC3E}">
+        <p14:creationId xmlns:p14="http://schemas.microsoft.com/office/powerpoint/2010/main" val="696866887"/>
+      </p:ext>
+    </p:extLst>
+  </p:cSld>
+  <p:clrMapOvr>
+    <a:masterClrMapping/>
+  </p:clrMapOvr>
+</p:sld>
+</file>
+
+<file path=ppt/slides/slide3.xml><?xml version="1.0" encoding="utf-8"?>
+<p:sld xmlns:a="http://schemas.openxmlformats.org/drawingml/2006/main" xmlns:r="http://schemas.openxmlformats.org/officeDocument/2006/relationships" xmlns:p="http://schemas.openxmlformats.org/presentationml/2006/main">
+  <p:cSld>
+    <p:spTree>
+      <p:nvGrpSpPr>
+        <p:cNvPr id="1" name="">
+          <a:extLst>
+            <a:ext uri="{FF2B5EF4-FFF2-40B4-BE49-F238E27FC236}">
+              <a16:creationId xmlns:a16="http://schemas.microsoft.com/office/drawing/2014/main" id="{0C97F23E-16AC-2913-6543-BEC1B6D30D8E}"/>
+            </a:ext>
+          </a:extLst>
+        </p:cNvPr>
+        <p:cNvGrpSpPr/>
+        <p:nvPr/>
+      </p:nvGrpSpPr>
+      <p:grpSpPr>
+        <a:xfrm>
+          <a:off x="0" y="0"/>
+          <a:ext cx="0" cy="0"/>
+          <a:chOff x="0" y="0"/>
+          <a:chExt cx="0" cy="0"/>
+        </a:xfrm>
+      </p:grpSpPr>
+      <p:sp>
+        <p:nvSpPr>
+          <p:cNvPr id="2" name="Title 1">
+            <a:extLst>
+              <a:ext uri="{FF2B5EF4-FFF2-40B4-BE49-F238E27FC236}">
+                <a16:creationId xmlns:a16="http://schemas.microsoft.com/office/drawing/2014/main" id="{87B8F006-B50D-2B02-A0EB-288F977AD3DF}"/>
+              </a:ext>
+            </a:extLst>
+          </p:cNvPr>
+          <p:cNvSpPr>
+            <a:spLocks noGrp="1"/>
+          </p:cNvSpPr>
+          <p:nvPr>
+            <p:ph type="title"/>
+          </p:nvPr>
+        </p:nvSpPr>
+        <p:spPr/>
+        <p:txBody>
+          <a:bodyPr/>
+          <a:lstStyle/>
+          <a:p>
+            <a:r>
+              <a:rPr lang="en-US" dirty="0"/>
+              <a:t>API &amp; Data Collection Process</a:t>
+            </a:r>
+          </a:p>
+        </p:txBody>
+      </p:sp>
+      <p:sp>
+        <p:nvSpPr>
+          <p:cNvPr id="3" name="TextBox 2">
+            <a:extLst>
+              <a:ext uri="{FF2B5EF4-FFF2-40B4-BE49-F238E27FC236}">
+                <a16:creationId xmlns:a16="http://schemas.microsoft.com/office/drawing/2014/main" id="{5FC528D7-F7D4-2BD2-8811-E813BCAB9628}"/>
+              </a:ext>
+            </a:extLst>
+          </p:cNvPr>
+          <p:cNvSpPr txBox="1"/>
+          <p:nvPr/>
+        </p:nvSpPr>
+        <p:spPr>
+          <a:xfrm>
+            <a:off x="838200" y="1450056"/>
+            <a:ext cx="10439400" cy="4739759"/>
+          </a:xfrm>
+          <a:prstGeom prst="rect">
+            <a:avLst/>
+          </a:prstGeom>
+          <a:noFill/>
+        </p:spPr>
+        <p:txBody>
+          <a:bodyPr wrap="square" rtlCol="0">
+            <a:spAutoFit/>
+          </a:bodyPr>
+          <a:lstStyle/>
+          <a:p>
+            <a:pPr marL="285750" indent="-285750">
+              <a:buFont typeface="Wingdings" panose="05000000000000000000" pitchFamily="2" charset="2"/>
+              <a:buChar char="v"/>
+            </a:pPr>
+            <a:r>
+              <a:rPr lang="nb-NO" sz="1500" dirty="0"/>
+              <a:t>HUD Fair Market Rent API (huduser.gov) </a:t>
+            </a:r>
+          </a:p>
+          <a:p>
+            <a:pPr marL="285750" indent="-285750">
+              <a:buFont typeface="Wingdings" panose="05000000000000000000" pitchFamily="2" charset="2"/>
+              <a:buChar char="v"/>
+            </a:pPr>
+            <a:r>
+              <a:rPr lang="nb-NO" sz="1500" dirty="0"/>
+              <a:t>HUD API Documentation Location: </a:t>
+            </a:r>
+            <a:r>
+              <a:rPr lang="en-US" sz="1500" dirty="0"/>
+              <a:t>huduser.gov → Datasets → Fair Market Rents → API Documentation</a:t>
+            </a:r>
+            <a:endParaRPr lang="nb-NO" sz="1500" dirty="0"/>
+          </a:p>
+          <a:p>
+            <a:pPr marL="285750" indent="-285750">
+              <a:buFont typeface="Wingdings" panose="05000000000000000000" pitchFamily="2" charset="2"/>
+              <a:buChar char="v"/>
+            </a:pPr>
+            <a:r>
+              <a:rPr lang="en-US" sz="1500" dirty="0"/>
+              <a:t>The </a:t>
+            </a:r>
+            <a:r>
+              <a:rPr lang="en-US" sz="1500" dirty="0">
+                <a:hlinkClick r:id="rId2"/>
+              </a:rPr>
+              <a:t>API documentation </a:t>
+            </a:r>
+            <a:r>
+              <a:rPr lang="en-US" sz="1500" dirty="0"/>
+              <a:t>was straightforward to navigate, it clearly listed the available endpoints and what data each one returned</a:t>
+            </a:r>
+          </a:p>
+          <a:p>
+            <a:pPr marL="285750" indent="-285750">
+              <a:buFont typeface="Wingdings" panose="05000000000000000000" pitchFamily="2" charset="2"/>
+              <a:buChar char="v"/>
+            </a:pPr>
+            <a:r>
+              <a:rPr lang="en-US" sz="1600" dirty="0"/>
+              <a:t>Before writing the full loop, I made a single API call for one state to explore the JSON response and understand the structure of the data, so I could identify which variables I needed.</a:t>
+            </a:r>
+          </a:p>
+          <a:p>
+            <a:pPr marL="285750" indent="-285750">
+              <a:buFont typeface="Wingdings" panose="05000000000000000000" pitchFamily="2" charset="2"/>
+              <a:buChar char="v"/>
+            </a:pPr>
+            <a:r>
+              <a:rPr lang="en-US" sz="1500" dirty="0"/>
+              <a:t>To get the list of states, I used the </a:t>
+            </a:r>
+            <a:r>
+              <a:rPr lang="en-US" sz="1500" dirty="0" err="1"/>
+              <a:t>fmr</a:t>
+            </a:r>
+            <a:r>
+              <a:rPr lang="en-US" sz="1500" dirty="0"/>
+              <a:t>/</a:t>
+            </a:r>
+            <a:r>
+              <a:rPr lang="en-US" sz="1500" dirty="0" err="1"/>
+              <a:t>listStates</a:t>
+            </a:r>
+            <a:r>
+              <a:rPr lang="en-US" sz="1500" dirty="0"/>
+              <a:t> endpoint to retrieve all state codes rather than hardcoding them</a:t>
+            </a:r>
+          </a:p>
+          <a:p>
+            <a:pPr marL="285750" indent="-285750">
+              <a:buFont typeface="Wingdings" panose="05000000000000000000" pitchFamily="2" charset="2"/>
+              <a:buChar char="v"/>
+            </a:pPr>
+            <a:endParaRPr lang="en-US" sz="1500" dirty="0"/>
+          </a:p>
+          <a:p>
+            <a:pPr marL="285750" indent="-285750">
+              <a:buFont typeface="Wingdings" panose="05000000000000000000" pitchFamily="2" charset="2"/>
+              <a:buChar char="v"/>
+            </a:pPr>
+            <a:endParaRPr lang="en-US" sz="1500" dirty="0"/>
+          </a:p>
+          <a:p>
+            <a:pPr marL="285750" indent="-285750">
+              <a:buFont typeface="Wingdings" panose="05000000000000000000" pitchFamily="2" charset="2"/>
+              <a:buChar char="v"/>
+            </a:pPr>
+            <a:endParaRPr lang="en-US" sz="1500" dirty="0"/>
+          </a:p>
+          <a:p>
+            <a:pPr marL="285750" indent="-285750">
+              <a:buFont typeface="Wingdings" panose="05000000000000000000" pitchFamily="2" charset="2"/>
+              <a:buChar char="v"/>
+            </a:pPr>
+            <a:endParaRPr lang="en-US" sz="1500" dirty="0"/>
+          </a:p>
+          <a:p>
+            <a:pPr marL="285750" indent="-285750">
+              <a:buFont typeface="Wingdings" panose="05000000000000000000" pitchFamily="2" charset="2"/>
+              <a:buChar char="v"/>
+            </a:pPr>
+            <a:r>
+              <a:rPr lang="en-US" sz="1500" dirty="0"/>
+              <a:t>I then looped through each state code, queried the </a:t>
+            </a:r>
+            <a:r>
+              <a:rPr lang="en-US" sz="1500" dirty="0" err="1"/>
+              <a:t>fmr</a:t>
+            </a:r>
+            <a:r>
+              <a:rPr lang="en-US" sz="1500" dirty="0"/>
+              <a:t>/</a:t>
+            </a:r>
+            <a:r>
+              <a:rPr lang="en-US" sz="1500" dirty="0" err="1"/>
+              <a:t>statedata</a:t>
+            </a:r>
+            <a:r>
+              <a:rPr lang="en-US" sz="1500" dirty="0"/>
+              <a:t>/{state} endpoint for 2023 data, and aggregated the results into a single </a:t>
+            </a:r>
+            <a:r>
+              <a:rPr lang="en-US" sz="1500" dirty="0" err="1"/>
+              <a:t>dataframe</a:t>
+            </a:r>
+            <a:r>
+              <a:rPr lang="en-US" sz="1500" dirty="0"/>
+              <a:t> containing county-level Fair Market Rent data</a:t>
+            </a:r>
+          </a:p>
+          <a:p>
+            <a:pPr marL="285750" indent="-285750">
+              <a:buFont typeface="Wingdings" panose="05000000000000000000" pitchFamily="2" charset="2"/>
+              <a:buChar char="v"/>
+            </a:pPr>
+            <a:endParaRPr lang="en-US" sz="1500" dirty="0"/>
+          </a:p>
+          <a:p>
+            <a:pPr marL="285750" indent="-285750">
+              <a:buFont typeface="Wingdings" panose="05000000000000000000" pitchFamily="2" charset="2"/>
+              <a:buChar char="v"/>
+            </a:pPr>
+            <a:endParaRPr lang="en-US" sz="1500" dirty="0"/>
+          </a:p>
+          <a:p>
+            <a:pPr marL="285750" indent="-285750">
+              <a:buFont typeface="Wingdings" panose="05000000000000000000" pitchFamily="2" charset="2"/>
+              <a:buChar char="v"/>
+            </a:pPr>
+            <a:endParaRPr lang="en-US" sz="1500" dirty="0"/>
+          </a:p>
+          <a:p>
+            <a:pPr marL="285750" indent="-285750">
+              <a:buFont typeface="Wingdings" panose="05000000000000000000" pitchFamily="2" charset="2"/>
+              <a:buChar char="v"/>
+            </a:pPr>
+            <a:endParaRPr lang="en-US" sz="1500" dirty="0"/>
+          </a:p>
+          <a:p>
+            <a:pPr marL="285750" indent="-285750">
+              <a:buFont typeface="Wingdings" panose="05000000000000000000" pitchFamily="2" charset="2"/>
+              <a:buChar char="v"/>
+            </a:pPr>
+            <a:endParaRPr lang="en-US" sz="1500" dirty="0"/>
+          </a:p>
+          <a:p>
+            <a:endParaRPr lang="nb-NO" sz="1500" dirty="0"/>
+          </a:p>
+          <a:p>
+            <a:pPr marL="285750" indent="-285750">
+              <a:buFont typeface="Wingdings" panose="05000000000000000000" pitchFamily="2" charset="2"/>
+              <a:buChar char="v"/>
+            </a:pPr>
+            <a:r>
+              <a:rPr lang="nb-NO" sz="1500" dirty="0"/>
+              <a:t>Other variables were obtained through the </a:t>
+            </a:r>
+            <a:r>
+              <a:rPr lang="nb-NO" sz="1500" dirty="0">
+                <a:hlinkClick r:id="rId3"/>
+              </a:rPr>
+              <a:t>Census Bureau database </a:t>
+            </a:r>
+            <a:r>
+              <a:rPr lang="nb-NO" sz="1500" dirty="0"/>
+              <a:t>through CSV files </a:t>
+            </a:r>
+          </a:p>
+        </p:txBody>
+      </p:sp>
+      <p:pic>
+        <p:nvPicPr>
+          <p:cNvPr id="8" name="Picture 7">
+            <a:extLst>
+              <a:ext uri="{FF2B5EF4-FFF2-40B4-BE49-F238E27FC236}">
+                <a16:creationId xmlns:a16="http://schemas.microsoft.com/office/drawing/2014/main" id="{49C1C1E0-7E67-E50E-7B59-7FA09F9139E9}"/>
+              </a:ext>
+            </a:extLst>
+          </p:cNvPr>
+          <p:cNvPicPr>
+            <a:picLocks noChangeAspect="1"/>
+          </p:cNvPicPr>
+          <p:nvPr/>
+        </p:nvPicPr>
+        <p:blipFill>
+          <a:blip r:embed="rId4">
+            <a:extLst>
+              <a:ext uri="{28A0092B-C50C-407E-A947-70E740481C1C}">
+                <a14:useLocalDpi xmlns:a14="http://schemas.microsoft.com/office/drawing/2010/main" val="0"/>
+              </a:ext>
+            </a:extLst>
+          </a:blip>
+          <a:stretch>
+            <a:fillRect/>
+          </a:stretch>
+        </p:blipFill>
+        <p:spPr>
+          <a:xfrm>
+            <a:off x="3632383" y="3108232"/>
+            <a:ext cx="3086050" cy="926834"/>
+          </a:xfrm>
+          <a:prstGeom prst="rect">
+            <a:avLst/>
+          </a:prstGeom>
+        </p:spPr>
+      </p:pic>
+      <p:pic>
+        <p:nvPicPr>
+          <p:cNvPr id="12" name="Picture 11">
+            <a:extLst>
+              <a:ext uri="{FF2B5EF4-FFF2-40B4-BE49-F238E27FC236}">
+                <a16:creationId xmlns:a16="http://schemas.microsoft.com/office/drawing/2014/main" id="{07F84D41-0128-4E91-DF7E-E684BCFC94B7}"/>
+              </a:ext>
+            </a:extLst>
+          </p:cNvPr>
+          <p:cNvPicPr>
+            <a:picLocks noChangeAspect="1"/>
+          </p:cNvPicPr>
+          <p:nvPr/>
+        </p:nvPicPr>
+        <p:blipFill>
+          <a:blip r:embed="rId5">
+            <a:extLst>
+              <a:ext uri="{28A0092B-C50C-407E-A947-70E740481C1C}">
+                <a14:useLocalDpi xmlns:a14="http://schemas.microsoft.com/office/drawing/2010/main" val="0"/>
+              </a:ext>
+            </a:extLst>
+          </a:blip>
+          <a:stretch>
+            <a:fillRect/>
+          </a:stretch>
+        </p:blipFill>
+        <p:spPr>
+          <a:xfrm>
+            <a:off x="3432422" y="4551085"/>
+            <a:ext cx="5085936" cy="1137824"/>
+          </a:xfrm>
+          <a:prstGeom prst="rect">
+            <a:avLst/>
+          </a:prstGeom>
+        </p:spPr>
+      </p:pic>
+    </p:spTree>
+    <p:extLst>
+      <p:ext uri="{BB962C8B-B14F-4D97-AF65-F5344CB8AC3E}">
+        <p14:creationId xmlns:p14="http://schemas.microsoft.com/office/powerpoint/2010/main" val="3782647756"/>
+      </p:ext>
+    </p:extLst>
+  </p:cSld>
+  <p:clrMapOvr>
+    <a:masterClrMapping/>
+  </p:clrMapOvr>
+</p:sld>
+</file>
+
+<file path=ppt/slides/slide4.xml><?xml version="1.0" encoding="utf-8"?>
+<p:sld xmlns:a="http://schemas.openxmlformats.org/drawingml/2006/main" xmlns:r="http://schemas.openxmlformats.org/officeDocument/2006/relationships" xmlns:p="http://schemas.openxmlformats.org/presentationml/2006/main">
+  <p:cSld>
+    <p:spTree>
+      <p:nvGrpSpPr>
+        <p:cNvPr id="1" name="">
+          <a:extLst>
+            <a:ext uri="{FF2B5EF4-FFF2-40B4-BE49-F238E27FC236}">
+              <a16:creationId xmlns:a16="http://schemas.microsoft.com/office/drawing/2014/main" id="{465DBD32-7D83-13EC-7D62-7D729DCCFA30}"/>
+            </a:ext>
+          </a:extLst>
+        </p:cNvPr>
+        <p:cNvGrpSpPr/>
+        <p:nvPr/>
+      </p:nvGrpSpPr>
+      <p:grpSpPr>
+        <a:xfrm>
+          <a:off x="0" y="0"/>
+          <a:ext cx="0" cy="0"/>
+          <a:chOff x="0" y="0"/>
+          <a:chExt cx="0" cy="0"/>
+        </a:xfrm>
+      </p:grpSpPr>
+      <p:pic>
+        <p:nvPicPr>
+          <p:cNvPr id="7" name="Picture 6">
+            <a:extLst>
+              <a:ext uri="{FF2B5EF4-FFF2-40B4-BE49-F238E27FC236}">
+                <a16:creationId xmlns:a16="http://schemas.microsoft.com/office/drawing/2014/main" id="{C5386D65-95D1-50E3-BA41-45A20A609B67}"/>
+              </a:ext>
+            </a:extLst>
+          </p:cNvPr>
+          <p:cNvPicPr>
+            <a:picLocks noChangeAspect="1"/>
+          </p:cNvPicPr>
+          <p:nvPr/>
+        </p:nvPicPr>
+        <p:blipFill>
+          <a:blip r:embed="rId2">
+            <a:extLst>
+              <a:ext uri="{28A0092B-C50C-407E-A947-70E740481C1C}">
+                <a14:useLocalDpi xmlns:a14="http://schemas.microsoft.com/office/drawing/2010/main" val="0"/>
+              </a:ext>
+            </a:extLst>
+          </a:blip>
+          <a:stretch>
+            <a:fillRect/>
+          </a:stretch>
+        </p:blipFill>
+        <p:spPr>
+          <a:xfrm>
+            <a:off x="1029903" y="298382"/>
+            <a:ext cx="9705769" cy="4591252"/>
+          </a:xfrm>
+          <a:prstGeom prst="rect">
+            <a:avLst/>
+          </a:prstGeom>
+        </p:spPr>
+      </p:pic>
+    </p:spTree>
+    <p:extLst>
+      <p:ext uri="{BB962C8B-B14F-4D97-AF65-F5344CB8AC3E}">
+        <p14:creationId xmlns:p14="http://schemas.microsoft.com/office/powerpoint/2010/main" val="2786174565"/>
+      </p:ext>
+    </p:extLst>
+  </p:cSld>
+  <p:clrMapOvr>
+    <a:masterClrMapping/>
+  </p:clrMapOvr>
+</p:sld>
+</file>
+
+<file path=ppt/slides/slide5.xml><?xml version="1.0" encoding="utf-8"?>
+<p:sld xmlns:a="http://schemas.openxmlformats.org/drawingml/2006/main" xmlns:r="http://schemas.openxmlformats.org/officeDocument/2006/relationships" xmlns:p="http://schemas.openxmlformats.org/presentationml/2006/main">
+  <p:cSld>
+    <p:spTree>
+      <p:nvGrpSpPr>
+        <p:cNvPr id="1" name="">
+          <a:extLst>
+            <a:ext uri="{FF2B5EF4-FFF2-40B4-BE49-F238E27FC236}">
+              <a16:creationId xmlns:a16="http://schemas.microsoft.com/office/drawing/2014/main" id="{B5A26398-428C-7B05-F3BB-31F2B8D2D99F}"/>
+            </a:ext>
+          </a:extLst>
+        </p:cNvPr>
+        <p:cNvGrpSpPr/>
+        <p:nvPr/>
+      </p:nvGrpSpPr>
+      <p:grpSpPr>
+        <a:xfrm>
+          <a:off x="0" y="0"/>
+          <a:ext cx="0" cy="0"/>
+          <a:chOff x="0" y="0"/>
+          <a:chExt cx="0" cy="0"/>
+        </a:xfrm>
+      </p:grpSpPr>
+      <p:pic>
+        <p:nvPicPr>
+          <p:cNvPr id="3" name="Picture 2">
+            <a:extLst>
+              <a:ext uri="{FF2B5EF4-FFF2-40B4-BE49-F238E27FC236}">
+                <a16:creationId xmlns:a16="http://schemas.microsoft.com/office/drawing/2014/main" id="{15D04751-230A-CF97-A233-D2E7B937977B}"/>
+              </a:ext>
+            </a:extLst>
+          </p:cNvPr>
+          <p:cNvPicPr>
+            <a:picLocks noChangeAspect="1"/>
+          </p:cNvPicPr>
+          <p:nvPr/>
+        </p:nvPicPr>
+        <p:blipFill>
+          <a:blip r:embed="rId2">
+            <a:extLst>
+              <a:ext uri="{28A0092B-C50C-407E-A947-70E740481C1C}">
+                <a14:useLocalDpi xmlns:a14="http://schemas.microsoft.com/office/drawing/2010/main" val="0"/>
+              </a:ext>
+            </a:extLst>
+          </a:blip>
+          <a:stretch>
+            <a:fillRect/>
+          </a:stretch>
+        </p:blipFill>
+        <p:spPr>
+          <a:xfrm>
+            <a:off x="1510008" y="249291"/>
+            <a:ext cx="8746549" cy="6074505"/>
+          </a:xfrm>
+          <a:prstGeom prst="rect">
+            <a:avLst/>
+          </a:prstGeom>
+        </p:spPr>
+      </p:pic>
+    </p:spTree>
+    <p:extLst>
+      <p:ext uri="{BB962C8B-B14F-4D97-AF65-F5344CB8AC3E}">
+        <p14:creationId xmlns:p14="http://schemas.microsoft.com/office/powerpoint/2010/main" val="1629346611"/>
+      </p:ext>
+    </p:extLst>
+  </p:cSld>
+  <p:clrMapOvr>
+    <a:masterClrMapping/>
+  </p:clrMapOvr>
+</p:sld>
+</file>
+
+<file path=ppt/slides/slide6.xml><?xml version="1.0" encoding="utf-8"?>
+<p:sld xmlns:a="http://schemas.openxmlformats.org/drawingml/2006/main" xmlns:r="http://schemas.openxmlformats.org/officeDocument/2006/relationships" xmlns:p="http://schemas.openxmlformats.org/presentationml/2006/main">
+  <p:cSld>
+    <p:spTree>
+      <p:nvGrpSpPr>
+        <p:cNvPr id="1" name="">
+          <a:extLst>
+            <a:ext uri="{FF2B5EF4-FFF2-40B4-BE49-F238E27FC236}">
+              <a16:creationId xmlns:a16="http://schemas.microsoft.com/office/drawing/2014/main" id="{00528810-2967-807F-44D7-47DD749B5624}"/>
+            </a:ext>
+          </a:extLst>
+        </p:cNvPr>
+        <p:cNvGrpSpPr/>
+        <p:nvPr/>
+      </p:nvGrpSpPr>
+      <p:grpSpPr>
+        <a:xfrm>
+          <a:off x="0" y="0"/>
+          <a:ext cx="0" cy="0"/>
+          <a:chOff x="0" y="0"/>
+          <a:chExt cx="0" cy="0"/>
+        </a:xfrm>
+      </p:grpSpPr>
+      <p:pic>
+        <p:nvPicPr>
+          <p:cNvPr id="6" name="Picture 5">
+            <a:extLst>
+              <a:ext uri="{FF2B5EF4-FFF2-40B4-BE49-F238E27FC236}">
+                <a16:creationId xmlns:a16="http://schemas.microsoft.com/office/drawing/2014/main" id="{78FD8723-8AFB-BA0C-FC26-76D066F26F87}"/>
+              </a:ext>
+            </a:extLst>
+          </p:cNvPr>
+          <p:cNvPicPr>
+            <a:picLocks noChangeAspect="1"/>
+          </p:cNvPicPr>
+          <p:nvPr/>
+        </p:nvPicPr>
+        <p:blipFill>
+          <a:blip r:embed="rId2">
+            <a:extLst>
+              <a:ext uri="{28A0092B-C50C-407E-A947-70E740481C1C}">
+                <a14:useLocalDpi xmlns:a14="http://schemas.microsoft.com/office/drawing/2010/main" val="0"/>
+              </a:ext>
+            </a:extLst>
+          </a:blip>
+          <a:stretch>
+            <a:fillRect/>
+          </a:stretch>
+        </p:blipFill>
+        <p:spPr>
+          <a:xfrm>
+            <a:off x="444226" y="666018"/>
+            <a:ext cx="11303547" cy="5525963"/>
+          </a:xfrm>
+          <a:prstGeom prst="rect">
+            <a:avLst/>
+          </a:prstGeom>
+        </p:spPr>
+      </p:pic>
+    </p:spTree>
+    <p:extLst>
+      <p:ext uri="{BB962C8B-B14F-4D97-AF65-F5344CB8AC3E}">
+        <p14:creationId xmlns:p14="http://schemas.microsoft.com/office/powerpoint/2010/main" val="306443379"/>
+      </p:ext>
+    </p:extLst>
+  </p:cSld>
+  <p:clrMapOvr>
+    <a:masterClrMapping/>
+  </p:clrMapOvr>
+</p:sld>
+</file>
+
+<file path=ppt/slides/slide7.xml><?xml version="1.0" encoding="utf-8"?>
+<p:sld xmlns:a="http://schemas.openxmlformats.org/drawingml/2006/main" xmlns:r="http://schemas.openxmlformats.org/officeDocument/2006/relationships" xmlns:p="http://schemas.openxmlformats.org/presentationml/2006/main">
+  <p:cSld>
+    <p:spTree>
+      <p:nvGrpSpPr>
+        <p:cNvPr id="1" name="">
+          <a:extLst>
+            <a:ext uri="{FF2B5EF4-FFF2-40B4-BE49-F238E27FC236}">
+              <a16:creationId xmlns:a16="http://schemas.microsoft.com/office/drawing/2014/main" id="{091A8C68-A114-28B9-130E-ECA0C063CBFF}"/>
+            </a:ext>
+          </a:extLst>
+        </p:cNvPr>
+        <p:cNvGrpSpPr/>
+        <p:nvPr/>
+      </p:nvGrpSpPr>
+      <p:grpSpPr>
+        <a:xfrm>
+          <a:off x="0" y="0"/>
+          <a:ext cx="0" cy="0"/>
+          <a:chOff x="0" y="0"/>
+          <a:chExt cx="0" cy="0"/>
+        </a:xfrm>
+      </p:grpSpPr>
+      <p:pic>
+        <p:nvPicPr>
+          <p:cNvPr id="3" name="Picture 2">
+            <a:extLst>
+              <a:ext uri="{FF2B5EF4-FFF2-40B4-BE49-F238E27FC236}">
+                <a16:creationId xmlns:a16="http://schemas.microsoft.com/office/drawing/2014/main" id="{81D147DD-B0F0-53B5-F086-BC0AB68D7E2D}"/>
+              </a:ext>
+            </a:extLst>
+          </p:cNvPr>
+          <p:cNvPicPr>
+            <a:picLocks noChangeAspect="1"/>
+          </p:cNvPicPr>
+          <p:nvPr/>
+        </p:nvPicPr>
+        <p:blipFill>
+          <a:blip r:embed="rId2">
+            <a:extLst>
+              <a:ext uri="{28A0092B-C50C-407E-A947-70E740481C1C}">
+                <a14:useLocalDpi xmlns:a14="http://schemas.microsoft.com/office/drawing/2010/main" val="0"/>
+              </a:ext>
+            </a:extLst>
+          </a:blip>
+          <a:stretch>
+            <a:fillRect/>
+          </a:stretch>
+        </p:blipFill>
+        <p:spPr>
+          <a:xfrm>
+            <a:off x="1873427" y="194383"/>
+            <a:ext cx="7838464" cy="3801090"/>
+          </a:xfrm>
+          <a:prstGeom prst="rect">
+            <a:avLst/>
+          </a:prstGeom>
+        </p:spPr>
+      </p:pic>
+      <p:pic>
+        <p:nvPicPr>
+          <p:cNvPr id="5" name="Picture 4">
+            <a:extLst>
+              <a:ext uri="{FF2B5EF4-FFF2-40B4-BE49-F238E27FC236}">
+                <a16:creationId xmlns:a16="http://schemas.microsoft.com/office/drawing/2014/main" id="{92628A3A-4152-5254-973B-26AC7464DCC0}"/>
+              </a:ext>
+            </a:extLst>
+          </p:cNvPr>
+          <p:cNvPicPr>
+            <a:picLocks noChangeAspect="1"/>
+          </p:cNvPicPr>
+          <p:nvPr/>
+        </p:nvPicPr>
+        <p:blipFill>
+          <a:blip r:embed="rId3">
+            <a:extLst>
+              <a:ext uri="{28A0092B-C50C-407E-A947-70E740481C1C}">
+                <a14:useLocalDpi xmlns:a14="http://schemas.microsoft.com/office/drawing/2010/main" val="0"/>
+              </a:ext>
+            </a:extLst>
+          </a:blip>
+          <a:stretch>
+            <a:fillRect/>
+          </a:stretch>
+        </p:blipFill>
+        <p:spPr>
+          <a:xfrm>
+            <a:off x="922461" y="4657997"/>
+            <a:ext cx="10347078" cy="705889"/>
+          </a:xfrm>
+          <a:prstGeom prst="rect">
+            <a:avLst/>
+          </a:prstGeom>
+        </p:spPr>
+      </p:pic>
+    </p:spTree>
+    <p:extLst>
+      <p:ext uri="{BB962C8B-B14F-4D97-AF65-F5344CB8AC3E}">
+        <p14:creationId xmlns:p14="http://schemas.microsoft.com/office/powerpoint/2010/main" val="458643595"/>
+      </p:ext>
+    </p:extLst>
+  </p:cSld>
+  <p:clrMapOvr>
+    <a:masterClrMapping/>
+  </p:clrMapOvr>
+</p:sld>
+</file>
+
+<file path=ppt/slides/slide8.xml><?xml version="1.0" encoding="utf-8"?>
+<p:sld xmlns:a="http://schemas.openxmlformats.org/drawingml/2006/main" xmlns:r="http://schemas.openxmlformats.org/officeDocument/2006/relationships" xmlns:p="http://schemas.openxmlformats.org/presentationml/2006/main">
+  <p:cSld>
+    <p:bg>
+      <p:bgPr>
+        <a:solidFill>
+          <a:schemeClr val="bg1"/>
+        </a:solidFill>
+        <a:effectLst/>
+      </p:bgPr>
+    </p:bg>
+    <p:spTree>
+      <p:nvGrpSpPr>
+        <p:cNvPr id="1" name="">
+          <a:extLst>
+            <a:ext uri="{FF2B5EF4-FFF2-40B4-BE49-F238E27FC236}">
+              <a16:creationId xmlns:a16="http://schemas.microsoft.com/office/drawing/2014/main" id="{EADAB4C0-A279-4ADA-A7EE-E3761EF7A809}"/>
+            </a:ext>
+          </a:extLst>
+        </p:cNvPr>
+        <p:cNvGrpSpPr/>
+        <p:nvPr/>
+      </p:nvGrpSpPr>
+      <p:grpSpPr>
+        <a:xfrm>
+          <a:off x="0" y="0"/>
+          <a:ext cx="0" cy="0"/>
+          <a:chOff x="0" y="0"/>
+          <a:chExt cx="0" cy="0"/>
+        </a:xfrm>
+      </p:grpSpPr>
+      <p:sp useBgFill="1">
+        <p:nvSpPr>
+          <p:cNvPr id="26" name="Rectangle 25">
+            <a:extLst>
+              <a:ext uri="{FF2B5EF4-FFF2-40B4-BE49-F238E27FC236}">
+                <a16:creationId xmlns:a16="http://schemas.microsoft.com/office/drawing/2014/main" id="{2151139A-886F-4B97-8815-729AD3831BBD}"/>
+              </a:ext>
+              <a:ext uri="{C183D7F6-B498-43B3-948B-1728B52AA6E4}">
+                <adec:decorative xmlns:adec="http://schemas.microsoft.com/office/drawing/2017/decorative" val="1"/>
+              </a:ext>
+            </a:extLst>
+          </p:cNvPr>
+          <p:cNvSpPr>
+            <a:spLocks noGrp="1" noRot="1" noChangeAspect="1" noMove="1" noResize="1" noEditPoints="1" noAdjustHandles="1" noChangeArrowheads="1" noChangeShapeType="1" noTextEdit="1"/>
+          </p:cNvSpPr>
+          <p:nvPr>
+            <p:extLst>
+              <p:ext uri="{386F3935-93C4-4BCD-93E2-E3B085C9AB24}">
+                <p16:designElem xmlns:p16="http://schemas.microsoft.com/office/powerpoint/2015/main" val="1"/>
+              </p:ext>
+            </p:extLst>
+          </p:nvPr>
+        </p:nvSpPr>
+        <p:spPr>
+          <a:xfrm>
+            <a:off x="0" y="0"/>
+            <a:ext cx="12192000" cy="6858000"/>
+          </a:xfrm>
+          <a:prstGeom prst="rect">
+            <a:avLst/>
+          </a:prstGeom>
+          <a:ln w="12700" cap="flat" cmpd="sng" algn="ctr">
+            <a:noFill/>
+            <a:prstDash val="solid"/>
+            <a:miter lim="800000"/>
+          </a:ln>
+          <a:effectLst/>
+          <a:extLst>
+            <a:ext uri="{91240B29-F687-4F45-9708-019B960494DF}">
+              <a14:hiddenLine xmlns:a14="http://schemas.microsoft.com/office/drawing/2010/main" w="12700" cap="flat" cmpd="sng" algn="ctr">
+                <a:solidFill>
+                  <a:schemeClr val="accent1">
+                    <a:shade val="50000"/>
+                  </a:schemeClr>
+                </a:solidFill>
+                <a:prstDash val="solid"/>
+                <a:miter lim="800000"/>
+              </a14:hiddenLine>
+            </a:ext>
+          </a:extLst>
+        </p:spPr>
+        <p:style>
+          <a:lnRef idx="2">
+            <a:schemeClr val="accent1">
+              <a:shade val="50000"/>
+            </a:schemeClr>
+          </a:lnRef>
+          <a:fillRef idx="1">
+            <a:schemeClr val="accent1"/>
+          </a:fillRef>
+          <a:effectRef idx="0">
+            <a:schemeClr val="accent1"/>
+          </a:effectRef>
+          <a:fontRef idx="minor">
+            <a:schemeClr val="lt1"/>
+          </a:fontRef>
+        </p:style>
+        <p:txBody>
+          <a:bodyPr rtlCol="0" anchor="ctr"/>
+          <a:lstStyle/>
+          <a:p>
+            <a:pPr algn="ctr"/>
+            <a:endParaRPr lang="en-US" sz="2000"/>
+          </a:p>
+        </p:txBody>
+      </p:sp>
+      <p:sp>
+        <p:nvSpPr>
+          <p:cNvPr id="28" name="Rectangle 27">
+            <a:extLst>
+              <a:ext uri="{FF2B5EF4-FFF2-40B4-BE49-F238E27FC236}">
+                <a16:creationId xmlns:a16="http://schemas.microsoft.com/office/drawing/2014/main" id="{AB5E08C4-8CDD-4623-A5B8-E998C6DEE3B7}"/>
+              </a:ext>
+              <a:ext uri="{C183D7F6-B498-43B3-948B-1728B52AA6E4}">
+                <adec:decorative xmlns:adec="http://schemas.microsoft.com/office/drawing/2017/decorative" val="1"/>
+              </a:ext>
+            </a:extLst>
+          </p:cNvPr>
+          <p:cNvSpPr>
+            <a:spLocks noGrp="1" noRot="1" noChangeAspect="1" noMove="1" noResize="1" noEditPoints="1" noAdjustHandles="1" noChangeArrowheads="1" noChangeShapeType="1" noTextEdit="1"/>
+          </p:cNvSpPr>
+          <p:nvPr>
+            <p:extLst>
+              <p:ext uri="{386F3935-93C4-4BCD-93E2-E3B085C9AB24}">
+                <p16:designElem xmlns:p16="http://schemas.microsoft.com/office/powerpoint/2015/main" val="1"/>
+              </p:ext>
+            </p:extLst>
+          </p:nvPr>
+        </p:nvSpPr>
+        <p:spPr>
+          <a:xfrm flipH="1">
+            <a:off x="2" y="492"/>
+            <a:ext cx="12191998" cy="1575955"/>
+          </a:xfrm>
+          <a:prstGeom prst="rect">
+            <a:avLst/>
+          </a:prstGeom>
+          <a:gradFill>
+            <a:gsLst>
+              <a:gs pos="0">
+                <a:schemeClr val="accent1">
+                  <a:lumMod val="50000"/>
+                </a:schemeClr>
+              </a:gs>
+              <a:gs pos="100000">
+                <a:schemeClr val="accent1">
+                  <a:lumMod val="75000"/>
+                </a:schemeClr>
+              </a:gs>
+            </a:gsLst>
+            <a:lin ang="8400000" scaled="0"/>
+          </a:gradFill>
+          <a:ln>
+            <a:noFill/>
+          </a:ln>
+        </p:spPr>
+        <p:style>
+          <a:lnRef idx="2">
+            <a:schemeClr val="accent1">
+              <a:shade val="50000"/>
+            </a:schemeClr>
+          </a:lnRef>
+          <a:fillRef idx="1">
+            <a:schemeClr val="accent1"/>
+          </a:fillRef>
+          <a:effectRef idx="0">
+            <a:schemeClr val="accent1"/>
+          </a:effectRef>
+          <a:fontRef idx="minor">
+            <a:schemeClr val="lt1"/>
+          </a:fontRef>
+        </p:style>
+        <p:txBody>
+          <a:bodyPr rtlCol="0" anchor="ctr"/>
+          <a:lstStyle/>
+          <a:p>
+            <a:pPr algn="ctr"/>
+            <a:endParaRPr lang="en-US"/>
+          </a:p>
+        </p:txBody>
+      </p:sp>
+      <p:sp>
+        <p:nvSpPr>
+          <p:cNvPr id="30" name="Rectangle 29">
+            <a:extLst>
+              <a:ext uri="{FF2B5EF4-FFF2-40B4-BE49-F238E27FC236}">
+                <a16:creationId xmlns:a16="http://schemas.microsoft.com/office/drawing/2014/main" id="{15F33878-D502-4FFA-8ACE-F2AECDB2A23F}"/>
+              </a:ext>
+              <a:ext uri="{C183D7F6-B498-43B3-948B-1728B52AA6E4}">
+                <adec:decorative xmlns:adec="http://schemas.microsoft.com/office/drawing/2017/decorative" val="1"/>
+              </a:ext>
+            </a:extLst>
+          </p:cNvPr>
+          <p:cNvSpPr>
+            <a:spLocks noGrp="1" noRot="1" noChangeAspect="1" noMove="1" noResize="1" noEditPoints="1" noAdjustHandles="1" noChangeArrowheads="1" noChangeShapeType="1" noTextEdit="1"/>
+          </p:cNvSpPr>
+          <p:nvPr>
+            <p:extLst>
+              <p:ext uri="{386F3935-93C4-4BCD-93E2-E3B085C9AB24}">
+                <p16:designElem xmlns:p16="http://schemas.microsoft.com/office/powerpoint/2015/main" val="1"/>
+              </p:ext>
+            </p:extLst>
+          </p:nvPr>
+        </p:nvSpPr>
+        <p:spPr>
+          <a:xfrm rot="10800000" flipH="1">
+            <a:off x="8128857" y="35"/>
+            <a:ext cx="4063143" cy="1576412"/>
+          </a:xfrm>
+          <a:prstGeom prst="rect">
+            <a:avLst/>
+          </a:prstGeom>
+          <a:gradFill>
+            <a:gsLst>
+              <a:gs pos="19000">
+                <a:schemeClr val="accent1">
+                  <a:lumMod val="50000"/>
+                  <a:alpha val="68000"/>
+                </a:schemeClr>
+              </a:gs>
+              <a:gs pos="100000">
+                <a:schemeClr val="accent1">
+                  <a:alpha val="79000"/>
+                </a:schemeClr>
+              </a:gs>
+            </a:gsLst>
+            <a:lin ang="19200000" scaled="0"/>
+          </a:gradFill>
+          <a:ln>
+            <a:noFill/>
+          </a:ln>
+        </p:spPr>
+        <p:style>
+          <a:lnRef idx="2">
+            <a:schemeClr val="accent1">
+              <a:shade val="50000"/>
+            </a:schemeClr>
+          </a:lnRef>
+          <a:fillRef idx="1">
+            <a:schemeClr val="accent1"/>
+          </a:fillRef>
+          <a:effectRef idx="0">
+            <a:schemeClr val="accent1"/>
+          </a:effectRef>
+          <a:fontRef idx="minor">
+            <a:schemeClr val="lt1"/>
+          </a:fontRef>
+        </p:style>
+        <p:txBody>
+          <a:bodyPr rtlCol="0" anchor="ctr"/>
+          <a:lstStyle/>
+          <a:p>
+            <a:pPr algn="ctr"/>
+            <a:endParaRPr lang="en-US"/>
+          </a:p>
+        </p:txBody>
+      </p:sp>
+      <p:sp>
+        <p:nvSpPr>
+          <p:cNvPr id="32" name="Rectangle 31">
+            <a:extLst>
+              <a:ext uri="{FF2B5EF4-FFF2-40B4-BE49-F238E27FC236}">
+                <a16:creationId xmlns:a16="http://schemas.microsoft.com/office/drawing/2014/main" id="{D3539FEE-81D3-4406-802E-60B20B16F4F6}"/>
+              </a:ext>
+              <a:ext uri="{C183D7F6-B498-43B3-948B-1728B52AA6E4}">
+                <adec:decorative xmlns:adec="http://schemas.microsoft.com/office/drawing/2017/decorative" val="1"/>
+              </a:ext>
+            </a:extLst>
+          </p:cNvPr>
+          <p:cNvSpPr>
+            <a:spLocks noGrp="1" noRot="1" noChangeAspect="1" noMove="1" noResize="1" noEditPoints="1" noAdjustHandles="1" noChangeArrowheads="1" noChangeShapeType="1" noTextEdit="1"/>
+          </p:cNvSpPr>
+          <p:nvPr>
+            <p:extLst>
+              <p:ext uri="{386F3935-93C4-4BCD-93E2-E3B085C9AB24}">
+                <p16:designElem xmlns:p16="http://schemas.microsoft.com/office/powerpoint/2015/main" val="1"/>
+              </p:ext>
+            </p:extLst>
+          </p:nvPr>
+        </p:nvSpPr>
+        <p:spPr>
+          <a:xfrm rot="5400000">
+            <a:off x="5307778" y="-5307777"/>
+            <a:ext cx="1576446" cy="12192001"/>
+          </a:xfrm>
+          <a:prstGeom prst="rect">
+            <a:avLst/>
+          </a:prstGeom>
+          <a:gradFill>
+            <a:gsLst>
+              <a:gs pos="16000">
+                <a:srgbClr val="000000">
+                  <a:alpha val="0"/>
+                </a:srgbClr>
+              </a:gs>
+              <a:gs pos="99000">
+                <a:srgbClr val="000000">
+                  <a:alpha val="87000"/>
+                </a:srgbClr>
+              </a:gs>
+            </a:gsLst>
+            <a:lin ang="11400000" scaled="0"/>
+          </a:gradFill>
+          <a:ln>
+            <a:noFill/>
+          </a:ln>
+        </p:spPr>
+        <p:style>
+          <a:lnRef idx="2">
+            <a:schemeClr val="accent1">
+              <a:shade val="50000"/>
+            </a:schemeClr>
+          </a:lnRef>
+          <a:fillRef idx="1">
+            <a:schemeClr val="accent1"/>
+          </a:fillRef>
+          <a:effectRef idx="0">
+            <a:schemeClr val="accent1"/>
+          </a:effectRef>
+          <a:fontRef idx="minor">
+            <a:schemeClr val="lt1"/>
+          </a:fontRef>
+        </p:style>
+        <p:txBody>
+          <a:bodyPr rtlCol="0" anchor="ctr"/>
+          <a:lstStyle/>
+          <a:p>
+            <a:pPr algn="ctr"/>
+            <a:endParaRPr lang="en-US" dirty="0"/>
+          </a:p>
+        </p:txBody>
+      </p:sp>
+      <p:sp>
+        <p:nvSpPr>
+          <p:cNvPr id="34" name="Rectangle 33">
+            <a:extLst>
+              <a:ext uri="{FF2B5EF4-FFF2-40B4-BE49-F238E27FC236}">
+                <a16:creationId xmlns:a16="http://schemas.microsoft.com/office/drawing/2014/main" id="{DC701763-729E-462F-A5A8-E0DEFEB1E2E4}"/>
+              </a:ext>
+              <a:ext uri="{C183D7F6-B498-43B3-948B-1728B52AA6E4}">
+                <adec:decorative xmlns:adec="http://schemas.microsoft.com/office/drawing/2017/decorative" val="1"/>
+              </a:ext>
+            </a:extLst>
+          </p:cNvPr>
+          <p:cNvSpPr>
+            <a:spLocks noGrp="1" noRot="1" noChangeAspect="1" noMove="1" noResize="1" noEditPoints="1" noAdjustHandles="1" noChangeArrowheads="1" noChangeShapeType="1" noTextEdit="1"/>
+          </p:cNvSpPr>
+          <p:nvPr>
+            <p:extLst>
+              <p:ext uri="{386F3935-93C4-4BCD-93E2-E3B085C9AB24}">
+                <p16:designElem xmlns:p16="http://schemas.microsoft.com/office/powerpoint/2015/main" val="1"/>
+              </p:ext>
+            </p:extLst>
+          </p:nvPr>
+        </p:nvSpPr>
+        <p:spPr>
+          <a:xfrm>
+            <a:off x="3825434" y="986"/>
+            <a:ext cx="4303422" cy="1575461"/>
+          </a:xfrm>
+          <a:prstGeom prst="rect">
+            <a:avLst/>
+          </a:prstGeom>
+          <a:gradFill>
+            <a:gsLst>
+              <a:gs pos="0">
+                <a:schemeClr val="accent1">
+                  <a:alpha val="17000"/>
+                </a:schemeClr>
+              </a:gs>
+              <a:gs pos="74000">
+                <a:schemeClr val="accent1">
+                  <a:lumMod val="50000"/>
+                  <a:alpha val="0"/>
+                </a:schemeClr>
+              </a:gs>
+            </a:gsLst>
+            <a:lin ang="14400000" scaled="0"/>
+          </a:gradFill>
+          <a:ln>
+            <a:noFill/>
+          </a:ln>
+        </p:spPr>
+        <p:style>
+          <a:lnRef idx="2">
+            <a:schemeClr val="accent1">
+              <a:shade val="50000"/>
+            </a:schemeClr>
+          </a:lnRef>
+          <a:fillRef idx="1">
+            <a:schemeClr val="accent1"/>
+          </a:fillRef>
+          <a:effectRef idx="0">
+            <a:schemeClr val="accent1"/>
+          </a:effectRef>
+          <a:fontRef idx="minor">
+            <a:schemeClr val="lt1"/>
+          </a:fontRef>
+        </p:style>
+        <p:txBody>
+          <a:bodyPr rtlCol="0" anchor="ctr"/>
+          <a:lstStyle/>
+          <a:p>
+            <a:pPr algn="ctr"/>
+            <a:endParaRPr lang="en-US"/>
+          </a:p>
+        </p:txBody>
+      </p:sp>
+      <p:sp>
+        <p:nvSpPr>
+          <p:cNvPr id="2" name="Title 1">
+            <a:extLst>
+              <a:ext uri="{FF2B5EF4-FFF2-40B4-BE49-F238E27FC236}">
+                <a16:creationId xmlns:a16="http://schemas.microsoft.com/office/drawing/2014/main" id="{BE75DB38-488B-73F3-D26D-1A009508A715}"/>
+              </a:ext>
+            </a:extLst>
+          </p:cNvPr>
+          <p:cNvSpPr>
+            <a:spLocks noGrp="1"/>
+          </p:cNvSpPr>
+          <p:nvPr>
+            <p:ph type="title"/>
+          </p:nvPr>
+        </p:nvSpPr>
+        <p:spPr>
+          <a:xfrm>
+            <a:off x="699714" y="353160"/>
+            <a:ext cx="7091300" cy="898581"/>
+          </a:xfrm>
+        </p:spPr>
+        <p:txBody>
+          <a:bodyPr vert="horz" lIns="91440" tIns="45720" rIns="91440" bIns="45720" rtlCol="0" anchor="ctr">
+            <a:normAutofit/>
+          </a:bodyPr>
+          <a:lstStyle/>
+          <a:p>
+            <a:r>
+              <a:rPr lang="en-US" sz="4000">
+                <a:solidFill>
+                  <a:srgbClr val="FFFFFF"/>
+                </a:solidFill>
+              </a:rPr>
+              <a:t>Graphs</a:t>
+            </a:r>
+          </a:p>
+        </p:txBody>
+      </p:sp>
+      <p:pic>
+        <p:nvPicPr>
+          <p:cNvPr id="7" name="Picture 6">
+            <a:extLst>
+              <a:ext uri="{FF2B5EF4-FFF2-40B4-BE49-F238E27FC236}">
+                <a16:creationId xmlns:a16="http://schemas.microsoft.com/office/drawing/2014/main" id="{0E97F157-548C-F1B7-7EE2-0D3669303996}"/>
+              </a:ext>
+            </a:extLst>
+          </p:cNvPr>
+          <p:cNvPicPr>
+            <a:picLocks noChangeAspect="1"/>
+          </p:cNvPicPr>
+          <p:nvPr/>
+        </p:nvPicPr>
+        <p:blipFill>
+          <a:blip r:embed="rId2">
+            <a:extLst>
+              <a:ext uri="{28A0092B-C50C-407E-A947-70E740481C1C}">
+                <a14:useLocalDpi xmlns:a14="http://schemas.microsoft.com/office/drawing/2010/main" val="0"/>
+              </a:ext>
+            </a:extLst>
+          </a:blip>
+          <a:stretch>
+            <a:fillRect/>
+          </a:stretch>
+        </p:blipFill>
+        <p:spPr>
+          <a:xfrm>
+            <a:off x="715748" y="2602436"/>
+            <a:ext cx="5131088" cy="3155617"/>
+          </a:xfrm>
+          <a:prstGeom prst="rect">
+            <a:avLst/>
+          </a:prstGeom>
+        </p:spPr>
+      </p:pic>
+      <p:pic>
+        <p:nvPicPr>
+          <p:cNvPr id="4" name="Picture 3">
+            <a:extLst>
+              <a:ext uri="{FF2B5EF4-FFF2-40B4-BE49-F238E27FC236}">
+                <a16:creationId xmlns:a16="http://schemas.microsoft.com/office/drawing/2014/main" id="{B0018D8A-B6DE-A8E5-BFFA-2841FEC916A5}"/>
+              </a:ext>
+            </a:extLst>
+          </p:cNvPr>
+          <p:cNvPicPr>
+            <a:picLocks noChangeAspect="1"/>
+          </p:cNvPicPr>
+          <p:nvPr/>
+        </p:nvPicPr>
+        <p:blipFill>
+          <a:blip r:embed="rId3">
+            <a:extLst>
+              <a:ext uri="{28A0092B-C50C-407E-A947-70E740481C1C}">
+                <a14:useLocalDpi xmlns:a14="http://schemas.microsoft.com/office/drawing/2010/main" val="0"/>
+              </a:ext>
+            </a:extLst>
+          </a:blip>
+          <a:stretch>
+            <a:fillRect/>
+          </a:stretch>
+        </p:blipFill>
+        <p:spPr>
+          <a:xfrm>
+            <a:off x="6345165" y="2350298"/>
+            <a:ext cx="5131087" cy="3732865"/>
+          </a:xfrm>
+          <a:prstGeom prst="rect">
+            <a:avLst/>
+          </a:prstGeom>
+        </p:spPr>
+      </p:pic>
+    </p:spTree>
+    <p:extLst>
+      <p:ext uri="{BB962C8B-B14F-4D97-AF65-F5344CB8AC3E}">
+        <p14:creationId xmlns:p14="http://schemas.microsoft.com/office/powerpoint/2010/main" val="3834200546"/>
+      </p:ext>
+    </p:extLst>
+  </p:cSld>
+  <p:clrMapOvr>
+    <a:masterClrMapping/>
+  </p:clrMapOvr>
+</p:sld>
+</file>
+
+<file path=ppt/slides/slide9.xml><?xml version="1.0" encoding="utf-8"?>
+<p:sld xmlns:a="http://schemas.openxmlformats.org/drawingml/2006/main" xmlns:r="http://schemas.openxmlformats.org/officeDocument/2006/relationships" xmlns:p="http://schemas.openxmlformats.org/presentationml/2006/main">
+  <p:cSld>
+    <p:spTree>
+      <p:nvGrpSpPr>
+        <p:cNvPr id="1" name="">
+          <a:extLst>
+            <a:ext uri="{FF2B5EF4-FFF2-40B4-BE49-F238E27FC236}">
+              <a16:creationId xmlns:a16="http://schemas.microsoft.com/office/drawing/2014/main" id="{184EEF7B-83C7-B71C-509C-AD3B46473B25}"/>
+            </a:ext>
+          </a:extLst>
+        </p:cNvPr>
+        <p:cNvGrpSpPr/>
+        <p:nvPr/>
+      </p:nvGrpSpPr>
+      <p:grpSpPr>
+        <a:xfrm>
+          <a:off x="0" y="0"/>
+          <a:ext cx="0" cy="0"/>
+          <a:chOff x="0" y="0"/>
+          <a:chExt cx="0" cy="0"/>
+        </a:xfrm>
+      </p:grpSpPr>
+      <p:sp>
+        <p:nvSpPr>
+          <p:cNvPr id="2" name="Title 1">
+            <a:extLst>
+              <a:ext uri="{FF2B5EF4-FFF2-40B4-BE49-F238E27FC236}">
+                <a16:creationId xmlns:a16="http://schemas.microsoft.com/office/drawing/2014/main" id="{3E17993E-39D1-CE04-9D42-1F9DE86B3401}"/>
+              </a:ext>
+            </a:extLst>
+          </p:cNvPr>
+          <p:cNvSpPr>
+            <a:spLocks noGrp="1"/>
+          </p:cNvSpPr>
+          <p:nvPr>
+            <p:ph type="title"/>
+          </p:nvPr>
+        </p:nvSpPr>
+        <p:spPr>
+          <a:xfrm>
+            <a:off x="699714" y="353160"/>
+            <a:ext cx="7091300" cy="898581"/>
+          </a:xfrm>
+        </p:spPr>
+        <p:txBody>
+          <a:bodyPr vert="horz" lIns="91440" tIns="45720" rIns="91440" bIns="45720" rtlCol="0" anchor="ctr">
+            <a:normAutofit/>
+          </a:bodyPr>
+          <a:lstStyle/>
+          <a:p>
+            <a:r>
+              <a:rPr lang="en-US" sz="4000">
+                <a:solidFill>
+                  <a:srgbClr val="FFFFFF"/>
+                </a:solidFill>
+              </a:rPr>
+              <a:t>Graphs</a:t>
+            </a:r>
+          </a:p>
+        </p:txBody>
+      </p:sp>
+      <p:pic>
+        <p:nvPicPr>
+          <p:cNvPr id="7" name="Picture 6">
+            <a:extLst>
+              <a:ext uri="{FF2B5EF4-FFF2-40B4-BE49-F238E27FC236}">
+                <a16:creationId xmlns:a16="http://schemas.microsoft.com/office/drawing/2014/main" id="{DC89EEB7-5692-EFBF-5FD1-7357A9E5CAD9}"/>
+              </a:ext>
+            </a:extLst>
+          </p:cNvPr>
+          <p:cNvPicPr>
+            <a:picLocks noChangeAspect="1"/>
+          </p:cNvPicPr>
+          <p:nvPr/>
+        </p:nvPicPr>
+        <p:blipFill>
+          <a:blip r:embed="rId2">
+            <a:extLst>
+              <a:ext uri="{28A0092B-C50C-407E-A947-70E740481C1C}">
+                <a14:useLocalDpi xmlns:a14="http://schemas.microsoft.com/office/drawing/2010/main" val="0"/>
+              </a:ext>
+            </a:extLst>
+          </a:blip>
+          <a:stretch>
+            <a:fillRect/>
+          </a:stretch>
+        </p:blipFill>
+        <p:spPr>
+          <a:xfrm>
+            <a:off x="0" y="4254091"/>
+            <a:ext cx="4031616" cy="2479442"/>
+          </a:xfrm>
+          <a:prstGeom prst="rect">
+            <a:avLst/>
+          </a:prstGeom>
+        </p:spPr>
+      </p:pic>
+      <p:pic>
+        <p:nvPicPr>
+          <p:cNvPr id="4" name="Picture 3">
+            <a:extLst>
+              <a:ext uri="{FF2B5EF4-FFF2-40B4-BE49-F238E27FC236}">
+                <a16:creationId xmlns:a16="http://schemas.microsoft.com/office/drawing/2014/main" id="{09884374-A222-D04E-EE99-43CF9877F22B}"/>
+              </a:ext>
+            </a:extLst>
+          </p:cNvPr>
+          <p:cNvPicPr>
+            <a:picLocks noChangeAspect="1"/>
+          </p:cNvPicPr>
+          <p:nvPr/>
+        </p:nvPicPr>
+        <p:blipFill>
+          <a:blip r:embed="rId3">
+            <a:extLst>
+              <a:ext uri="{28A0092B-C50C-407E-A947-70E740481C1C}">
+                <a14:useLocalDpi xmlns:a14="http://schemas.microsoft.com/office/drawing/2010/main" val="0"/>
+              </a:ext>
+            </a:extLst>
+          </a:blip>
+          <a:stretch>
+            <a:fillRect/>
+          </a:stretch>
+        </p:blipFill>
+        <p:spPr>
+          <a:xfrm>
+            <a:off x="194892" y="147050"/>
+            <a:ext cx="3503727" cy="2548961"/>
+          </a:xfrm>
+          <a:prstGeom prst="rect">
+            <a:avLst/>
+          </a:prstGeom>
+        </p:spPr>
+      </p:pic>
+      <p:pic>
+        <p:nvPicPr>
+          <p:cNvPr id="5" name="Picture 4">
+            <a:extLst>
+              <a:ext uri="{FF2B5EF4-FFF2-40B4-BE49-F238E27FC236}">
+                <a16:creationId xmlns:a16="http://schemas.microsoft.com/office/drawing/2014/main" id="{C27B7B12-1A2F-23FF-5072-D0B062433574}"/>
+              </a:ext>
+            </a:extLst>
+          </p:cNvPr>
+          <p:cNvPicPr>
+            <a:picLocks noChangeAspect="1"/>
+          </p:cNvPicPr>
+          <p:nvPr/>
+        </p:nvPicPr>
+        <p:blipFill>
+          <a:blip r:embed="rId4">
+            <a:extLst>
+              <a:ext uri="{28A0092B-C50C-407E-A947-70E740481C1C}">
+                <a14:useLocalDpi xmlns:a14="http://schemas.microsoft.com/office/drawing/2010/main" val="0"/>
+              </a:ext>
+            </a:extLst>
+          </a:blip>
+          <a:stretch>
+            <a:fillRect/>
+          </a:stretch>
+        </p:blipFill>
+        <p:spPr>
+          <a:xfrm>
+            <a:off x="3879026" y="238434"/>
+            <a:ext cx="8049046" cy="2687645"/>
+          </a:xfrm>
+          <a:prstGeom prst="rect">
+            <a:avLst/>
+          </a:prstGeom>
+        </p:spPr>
+      </p:pic>
+      <p:pic>
+        <p:nvPicPr>
+          <p:cNvPr id="8" name="Picture 7">
+            <a:extLst>
+              <a:ext uri="{FF2B5EF4-FFF2-40B4-BE49-F238E27FC236}">
+                <a16:creationId xmlns:a16="http://schemas.microsoft.com/office/drawing/2014/main" id="{4111B534-E254-90E2-81A4-B5D259190848}"/>
+              </a:ext>
+            </a:extLst>
+          </p:cNvPr>
+          <p:cNvPicPr>
+            <a:picLocks noChangeAspect="1"/>
+          </p:cNvPicPr>
+          <p:nvPr/>
+        </p:nvPicPr>
+        <p:blipFill>
+          <a:blip r:embed="rId5">
+            <a:extLst>
+              <a:ext uri="{28A0092B-C50C-407E-A947-70E740481C1C}">
+                <a14:useLocalDpi xmlns:a14="http://schemas.microsoft.com/office/drawing/2010/main" val="0"/>
+              </a:ext>
+            </a:extLst>
+          </a:blip>
+          <a:stretch>
+            <a:fillRect/>
+          </a:stretch>
+        </p:blipFill>
+        <p:spPr>
+          <a:xfrm>
+            <a:off x="4091949" y="4405359"/>
+            <a:ext cx="7910390" cy="1514178"/>
+          </a:xfrm>
+          <a:prstGeom prst="rect">
+            <a:avLst/>
+          </a:prstGeom>
+        </p:spPr>
+      </p:pic>
+    </p:spTree>
+    <p:extLst>
+      <p:ext uri="{BB962C8B-B14F-4D97-AF65-F5344CB8AC3E}">
+        <p14:creationId xmlns:p14="http://schemas.microsoft.com/office/powerpoint/2010/main" val="1978823791"/>
       </p:ext>
     </p:extLst>
   </p:cSld>

</xml_diff>